<commit_message>
Pitch v8: mark group-level figures with footnote, update team descriptions
Co-Authored-By: Claude Opus 5.5 <noreply@anthropic.com>
Claude-Session: https://claude.ai/code/session_01DZfKE2Qbh1BJBTBdA16C3f
</commit_message>
<xml_diff>
--- a/grant/Sodeystvie_pitch_v8.pptx
+++ b/grant/Sodeystvie_pitch_v8.pptx
@@ -2059,7 +2059,7 @@
                 <a:ea typeface="Arial" pitchFamily="34" charset="-122"/>
                 <a:cs typeface="Arial" pitchFamily="34" charset="-120"/>
               </a:rPr>
-              <a:t>3</a:t>
+              <a:t>3*</a:t>
             </a:r>
             <a:endParaRPr lang="en-US" sz="3600" dirty="0"/>
           </a:p>
@@ -2160,7 +2160,7 @@
                 <a:ea typeface="Arial" pitchFamily="34" charset="-122"/>
                 <a:cs typeface="Arial" pitchFamily="34" charset="-120"/>
               </a:rPr>
-              <a:t>955</a:t>
+              <a:t>955*</a:t>
             </a:r>
             <a:endParaRPr lang="en-US" sz="3600" dirty="0"/>
           </a:p>
@@ -2252,7 +2252,7 @@
         </p:nvSpPr>
         <p:spPr>
           <a:xfrm>
-            <a:off x="548640" y="6144768"/>
+            <a:off x="548640" y="6108192"/>
             <a:ext cx="6400800" cy="274320"/>
           </a:xfrm>
           <a:prstGeom prst="rect">
@@ -2280,6 +2280,45 @@
               <a:t>Руководитель Центра «Содействие» · Республика Татарстан</a:t>
             </a:r>
             <a:endParaRPr lang="en-US" sz="1300" dirty="0"/>
+          </a:p>
+        </p:txBody>
+      </p:sp>
+      <p:sp>
+        <p:nvSpPr>
+          <p:cNvPr id="19" name="Text 15"/>
+          <p:cNvSpPr txBox="1"/>
+          <p:nvPr/>
+        </p:nvSpPr>
+        <p:spPr>
+          <a:xfrm>
+            <a:off x="548640" y="6510528"/>
+            <a:ext cx="6035040" cy="274320"/>
+          </a:xfrm>
+          <a:prstGeom prst="rect">
+            <a:avLst/>
+          </a:prstGeom>
+          <a:noFill/>
+          <a:ln/>
+        </p:spPr>
+        <p:txBody>
+          <a:bodyPr wrap="square" lIns="0" tIns="0" rIns="0" bIns="0" rtlCol="0" anchor="t"/>
+          <a:lstStyle/>
+          <a:p>
+            <a:pPr indent="0" marL="0">
+              <a:buNone/>
+            </a:pPr>
+            <a:r>
+              <a:rPr lang="en-US" sz="800" i="1" dirty="0">
+                <a:solidFill>
+                  <a:srgbClr val="9CC7C2"/>
+                </a:solidFill>
+                <a:latin typeface="Arial" pitchFamily="34" charset="0"/>
+                <a:ea typeface="Arial" pitchFamily="34" charset="-122"/>
+                <a:cs typeface="Arial" pitchFamily="34" charset="-120"/>
+              </a:rPr>
+              <a:t>* Показатели группы организаций «Содействие»: АНО ЦСО «Содействие», АНО РЦСП «Содействие», АНО ПЦСП «Содействие» — единая система долговременного ухода</a:t>
+            </a:r>
+            <a:endParaRPr lang="en-US" sz="800" dirty="0"/>
           </a:p>
         </p:txBody>
       </p:sp>
@@ -2323,8 +2362,8 @@
         </p:nvSpPr>
         <p:spPr>
           <a:xfrm>
-            <a:off x="548640" y="6473952"/>
-            <a:ext cx="6400800" cy="201168"/>
+            <a:off x="548640" y="6565392"/>
+            <a:ext cx="6400800" cy="182880"/>
           </a:xfrm>
           <a:prstGeom prst="rect">
             <a:avLst/>
@@ -2362,8 +2401,8 @@
         </p:nvSpPr>
         <p:spPr>
           <a:xfrm>
-            <a:off x="10543032" y="6473952"/>
-            <a:ext cx="1097280" cy="201168"/>
+            <a:off x="10543032" y="6565392"/>
+            <a:ext cx="1097280" cy="182880"/>
           </a:xfrm>
           <a:prstGeom prst="rect">
             <a:avLst/>
@@ -4253,8 +4292,8 @@
         </p:nvSpPr>
         <p:spPr>
           <a:xfrm>
-            <a:off x="548640" y="6473952"/>
-            <a:ext cx="6400800" cy="201168"/>
+            <a:off x="548640" y="6565392"/>
+            <a:ext cx="6400800" cy="182880"/>
           </a:xfrm>
           <a:prstGeom prst="rect">
             <a:avLst/>
@@ -4292,8 +4331,8 @@
         </p:nvSpPr>
         <p:spPr>
           <a:xfrm>
-            <a:off x="10543032" y="6473952"/>
-            <a:ext cx="1097280" cy="201168"/>
+            <a:off x="10543032" y="6565392"/>
+            <a:ext cx="1097280" cy="182880"/>
           </a:xfrm>
           <a:prstGeom prst="rect">
             <a:avLst/>
@@ -4436,6 +4475,45 @@
         </p:nvSpPr>
         <p:spPr>
           <a:xfrm>
+            <a:off x="548640" y="6355080"/>
+            <a:ext cx="11091672" cy="182880"/>
+          </a:xfrm>
+          <a:prstGeom prst="rect">
+            <a:avLst/>
+          </a:prstGeom>
+          <a:noFill/>
+          <a:ln/>
+        </p:spPr>
+        <p:txBody>
+          <a:bodyPr wrap="square" lIns="0" tIns="0" rIns="0" bIns="0" rtlCol="0" anchor="t"/>
+          <a:lstStyle/>
+          <a:p>
+            <a:pPr indent="0" marL="0">
+              <a:buNone/>
+            </a:pPr>
+            <a:r>
+              <a:rPr lang="en-US" sz="850" i="1" dirty="0">
+                <a:solidFill>
+                  <a:srgbClr val="7A7A7A"/>
+                </a:solidFill>
+                <a:latin typeface="Arial" pitchFamily="34" charset="0"/>
+                <a:ea typeface="Arial" pitchFamily="34" charset="-122"/>
+                <a:cs typeface="Arial" pitchFamily="34" charset="-120"/>
+              </a:rPr>
+              <a:t>* Показатели группы организаций «Содействие»: АНО ЦСО «Содействие», АНО РЦСП «Содействие», АНО ПЦСП «Содействие» — единая система долговременного ухода</a:t>
+            </a:r>
+            <a:endParaRPr lang="en-US" sz="850" dirty="0"/>
+          </a:p>
+        </p:txBody>
+      </p:sp>
+      <p:sp>
+        <p:nvSpPr>
+          <p:cNvPr id="8" name="Text 6"/>
+          <p:cNvSpPr txBox="1"/>
+          <p:nvPr/>
+        </p:nvSpPr>
+        <p:spPr>
+          <a:xfrm>
             <a:off x="548640" y="1572768"/>
             <a:ext cx="4572000" cy="292608"/>
           </a:xfrm>
@@ -4469,7 +4547,7 @@
       </p:sp>
       <p:sp>
         <p:nvSpPr>
-          <p:cNvPr id="8" name="Shape 6"/>
+          <p:cNvPr id="9" name="Shape 7"/>
           <p:cNvSpPr/>
           <p:nvPr/>
         </p:nvSpPr>
@@ -4496,7 +4574,7 @@
       </p:sp>
       <p:sp>
         <p:nvSpPr>
-          <p:cNvPr id="9" name="Text 7"/>
+          <p:cNvPr id="10" name="Text 8"/>
           <p:cNvSpPr txBox="1"/>
           <p:nvPr/>
         </p:nvSpPr>
@@ -4524,7 +4602,7 @@
       </p:sp>
       <p:sp>
         <p:nvSpPr>
-          <p:cNvPr id="10" name="Text 8"/>
+          <p:cNvPr id="11" name="Text 9"/>
           <p:cNvSpPr txBox="1"/>
           <p:nvPr/>
         </p:nvSpPr>
@@ -4563,7 +4641,7 @@
       </p:sp>
       <p:sp>
         <p:nvSpPr>
-          <p:cNvPr id="11" name="Text 9"/>
+          <p:cNvPr id="12" name="Text 10"/>
           <p:cNvSpPr txBox="1"/>
           <p:nvPr/>
         </p:nvSpPr>
@@ -4602,7 +4680,7 @@
       </p:sp>
       <p:sp>
         <p:nvSpPr>
-          <p:cNvPr id="12" name="Text 10"/>
+          <p:cNvPr id="13" name="Text 11"/>
           <p:cNvSpPr txBox="1"/>
           <p:nvPr/>
         </p:nvSpPr>
@@ -4641,7 +4719,7 @@
       </p:sp>
       <p:sp>
         <p:nvSpPr>
-          <p:cNvPr id="13" name="Shape 11"/>
+          <p:cNvPr id="14" name="Shape 12"/>
           <p:cNvSpPr/>
           <p:nvPr/>
         </p:nvSpPr>
@@ -4664,7 +4742,7 @@
       </p:sp>
       <p:sp>
         <p:nvSpPr>
-          <p:cNvPr id="14" name="Text 12"/>
+          <p:cNvPr id="15" name="Text 13"/>
           <p:cNvSpPr txBox="1"/>
           <p:nvPr/>
         </p:nvSpPr>
@@ -4703,7 +4781,7 @@
       </p:sp>
       <p:pic>
         <p:nvPicPr>
-          <p:cNvPr id="15" name="Image 0" descr="preencoded.png">    </p:cNvPr>
+          <p:cNvPr id="16" name="Image 0" descr="preencoded.png">    </p:cNvPr>
           <p:cNvPicPr>
             <a:picLocks noChangeAspect="1"/>
           </p:cNvPicPr>
@@ -4727,7 +4805,7 @@
       </p:pic>
       <p:sp>
         <p:nvSpPr>
-          <p:cNvPr id="16" name="Text 13"/>
+          <p:cNvPr id="17" name="Text 14"/>
           <p:cNvSpPr txBox="1"/>
           <p:nvPr/>
         </p:nvSpPr>
@@ -4766,7 +4844,7 @@
       </p:sp>
       <p:pic>
         <p:nvPicPr>
-          <p:cNvPr id="17" name="Image 1" descr="preencoded.png">    </p:cNvPr>
+          <p:cNvPr id="18" name="Image 1" descr="preencoded.png">    </p:cNvPr>
           <p:cNvPicPr>
             <a:picLocks noChangeAspect="1"/>
           </p:cNvPicPr>
@@ -4790,7 +4868,7 @@
       </p:pic>
       <p:sp>
         <p:nvSpPr>
-          <p:cNvPr id="18" name="Text 14"/>
+          <p:cNvPr id="19" name="Text 15"/>
           <p:cNvSpPr txBox="1"/>
           <p:nvPr/>
         </p:nvSpPr>
@@ -4829,7 +4907,7 @@
       </p:sp>
       <p:pic>
         <p:nvPicPr>
-          <p:cNvPr id="19" name="Image 2" descr="preencoded.png">    </p:cNvPr>
+          <p:cNvPr id="20" name="Image 2" descr="preencoded.png">    </p:cNvPr>
           <p:cNvPicPr>
             <a:picLocks noChangeAspect="1"/>
           </p:cNvPicPr>
@@ -4853,7 +4931,7 @@
       </p:pic>
       <p:sp>
         <p:nvSpPr>
-          <p:cNvPr id="20" name="Text 15"/>
+          <p:cNvPr id="21" name="Text 16"/>
           <p:cNvSpPr txBox="1"/>
           <p:nvPr/>
         </p:nvSpPr>
@@ -4892,7 +4970,7 @@
       </p:sp>
       <p:sp>
         <p:nvSpPr>
-          <p:cNvPr id="21" name="Shape 16"/>
+          <p:cNvPr id="22" name="Shape 17"/>
           <p:cNvSpPr/>
           <p:nvPr/>
         </p:nvSpPr>
@@ -4915,7 +4993,7 @@
       </p:sp>
       <p:sp>
         <p:nvSpPr>
-          <p:cNvPr id="22" name="Text 17"/>
+          <p:cNvPr id="23" name="Text 18"/>
           <p:cNvSpPr txBox="1"/>
           <p:nvPr/>
         </p:nvSpPr>
@@ -4954,7 +5032,7 @@
       </p:sp>
       <p:pic>
         <p:nvPicPr>
-          <p:cNvPr id="23" name="Image 3" descr="preencoded.png">    </p:cNvPr>
+          <p:cNvPr id="24" name="Image 3" descr="preencoded.png">    </p:cNvPr>
           <p:cNvPicPr>
             <a:picLocks noChangeAspect="1"/>
           </p:cNvPicPr>
@@ -4978,7 +5056,7 @@
       </p:pic>
       <p:sp>
         <p:nvSpPr>
-          <p:cNvPr id="24" name="Text 18"/>
+          <p:cNvPr id="25" name="Text 19"/>
           <p:cNvSpPr txBox="1"/>
           <p:nvPr/>
         </p:nvSpPr>
@@ -5017,7 +5095,7 @@
       </p:sp>
       <p:pic>
         <p:nvPicPr>
-          <p:cNvPr id="25" name="Image 4" descr="preencoded.png">    </p:cNvPr>
+          <p:cNvPr id="26" name="Image 4" descr="preencoded.png">    </p:cNvPr>
           <p:cNvPicPr>
             <a:picLocks noChangeAspect="1"/>
           </p:cNvPicPr>
@@ -5041,7 +5119,7 @@
       </p:pic>
       <p:sp>
         <p:nvSpPr>
-          <p:cNvPr id="26" name="Text 19"/>
+          <p:cNvPr id="27" name="Text 20"/>
           <p:cNvSpPr txBox="1"/>
           <p:nvPr/>
         </p:nvSpPr>
@@ -5080,7 +5158,7 @@
       </p:sp>
       <p:pic>
         <p:nvPicPr>
-          <p:cNvPr id="27" name="Image 5" descr="preencoded.png">    </p:cNvPr>
+          <p:cNvPr id="28" name="Image 5" descr="preencoded.png">    </p:cNvPr>
           <p:cNvPicPr>
             <a:picLocks noChangeAspect="1"/>
           </p:cNvPicPr>
@@ -5104,7 +5182,7 @@
       </p:pic>
       <p:sp>
         <p:nvSpPr>
-          <p:cNvPr id="28" name="Text 20"/>
+          <p:cNvPr id="29" name="Text 21"/>
           <p:cNvSpPr txBox="1"/>
           <p:nvPr/>
         </p:nvSpPr>
@@ -5135,7 +5213,7 @@
                 <a:ea typeface="Arial" pitchFamily="34" charset="-122"/>
                 <a:cs typeface="Arial" pitchFamily="34" charset="-120"/>
               </a:rPr>
-              <a:t>1 500+ обученных</a:t>
+              <a:t>1 500+ обученных*</a:t>
             </a:r>
             <a:endParaRPr lang="en-US" sz="1250" dirty="0"/>
           </a:p>
@@ -5143,7 +5221,7 @@
       </p:sp>
       <p:sp>
         <p:nvSpPr>
-          <p:cNvPr id="29" name="Shape 21"/>
+          <p:cNvPr id="30" name="Shape 22"/>
           <p:cNvSpPr/>
           <p:nvPr/>
         </p:nvSpPr>
@@ -5166,7 +5244,7 @@
       </p:sp>
       <p:sp>
         <p:nvSpPr>
-          <p:cNvPr id="30" name="Text 22"/>
+          <p:cNvPr id="31" name="Text 23"/>
           <p:cNvSpPr txBox="1"/>
           <p:nvPr/>
         </p:nvSpPr>
@@ -5205,7 +5283,7 @@
       </p:sp>
       <p:pic>
         <p:nvPicPr>
-          <p:cNvPr id="31" name="Image 6" descr="preencoded.png">    </p:cNvPr>
+          <p:cNvPr id="32" name="Image 6" descr="preencoded.png">    </p:cNvPr>
           <p:cNvPicPr>
             <a:picLocks noChangeAspect="1"/>
           </p:cNvPicPr>
@@ -5229,7 +5307,7 @@
       </p:pic>
       <p:sp>
         <p:nvSpPr>
-          <p:cNvPr id="32" name="Text 23"/>
+          <p:cNvPr id="33" name="Text 24"/>
           <p:cNvSpPr txBox="1"/>
           <p:nvPr/>
         </p:nvSpPr>
@@ -5268,7 +5346,7 @@
       </p:sp>
       <p:pic>
         <p:nvPicPr>
-          <p:cNvPr id="33" name="Image 7" descr="preencoded.png">    </p:cNvPr>
+          <p:cNvPr id="34" name="Image 7" descr="preencoded.png">    </p:cNvPr>
           <p:cNvPicPr>
             <a:picLocks noChangeAspect="1"/>
           </p:cNvPicPr>
@@ -5292,7 +5370,7 @@
       </p:pic>
       <p:sp>
         <p:nvSpPr>
-          <p:cNvPr id="34" name="Text 24"/>
+          <p:cNvPr id="35" name="Text 25"/>
           <p:cNvSpPr txBox="1"/>
           <p:nvPr/>
         </p:nvSpPr>
@@ -5331,7 +5409,7 @@
       </p:sp>
       <p:pic>
         <p:nvPicPr>
-          <p:cNvPr id="35" name="Image 8" descr="preencoded.png">    </p:cNvPr>
+          <p:cNvPr id="36" name="Image 8" descr="preencoded.png">    </p:cNvPr>
           <p:cNvPicPr>
             <a:picLocks noChangeAspect="1"/>
           </p:cNvPicPr>
@@ -5355,7 +5433,7 @@
       </p:pic>
       <p:sp>
         <p:nvSpPr>
-          <p:cNvPr id="36" name="Text 25"/>
+          <p:cNvPr id="37" name="Text 26"/>
           <p:cNvSpPr txBox="1"/>
           <p:nvPr/>
         </p:nvSpPr>
@@ -5394,7 +5472,7 @@
       </p:sp>
       <p:sp>
         <p:nvSpPr>
-          <p:cNvPr id="37" name="Shape 26"/>
+          <p:cNvPr id="38" name="Shape 27"/>
           <p:cNvSpPr/>
           <p:nvPr/>
         </p:nvSpPr>
@@ -5428,7 +5506,7 @@
       </p:sp>
       <p:sp>
         <p:nvSpPr>
-          <p:cNvPr id="38" name="Text 27"/>
+          <p:cNvPr id="39" name="Text 28"/>
           <p:cNvSpPr txBox="1"/>
           <p:nvPr/>
         </p:nvSpPr>
@@ -5467,7 +5545,7 @@
       </p:sp>
       <p:sp>
         <p:nvSpPr>
-          <p:cNvPr id="39" name="Shape 28"/>
+          <p:cNvPr id="40" name="Shape 29"/>
           <p:cNvSpPr/>
           <p:nvPr/>
         </p:nvSpPr>
@@ -5492,7 +5570,7 @@
       </p:sp>
       <p:pic>
         <p:nvPicPr>
-          <p:cNvPr id="40" name="Image 9" descr="preencoded.png">    </p:cNvPr>
+          <p:cNvPr id="41" name="Image 9" descr="preencoded.png">    </p:cNvPr>
           <p:cNvPicPr>
             <a:picLocks noChangeAspect="1"/>
           </p:cNvPicPr>
@@ -5516,7 +5594,7 @@
       </p:pic>
       <p:sp>
         <p:nvSpPr>
-          <p:cNvPr id="41" name="Text 29"/>
+          <p:cNvPr id="42" name="Text 30"/>
           <p:cNvSpPr txBox="1"/>
           <p:nvPr/>
         </p:nvSpPr>
@@ -5555,7 +5633,7 @@
       </p:sp>
       <p:sp>
         <p:nvSpPr>
-          <p:cNvPr id="42" name="Shape 30"/>
+          <p:cNvPr id="43" name="Shape 31"/>
           <p:cNvSpPr/>
           <p:nvPr/>
         </p:nvSpPr>
@@ -5580,7 +5658,7 @@
       </p:sp>
       <p:pic>
         <p:nvPicPr>
-          <p:cNvPr id="43" name="Image 10" descr="preencoded.png">    </p:cNvPr>
+          <p:cNvPr id="44" name="Image 10" descr="preencoded.png">    </p:cNvPr>
           <p:cNvPicPr>
             <a:picLocks noChangeAspect="1"/>
           </p:cNvPicPr>
@@ -5604,7 +5682,7 @@
       </p:pic>
       <p:sp>
         <p:nvSpPr>
-          <p:cNvPr id="44" name="Text 31"/>
+          <p:cNvPr id="45" name="Text 32"/>
           <p:cNvSpPr txBox="1"/>
           <p:nvPr/>
         </p:nvSpPr>
@@ -5643,7 +5721,7 @@
       </p:sp>
       <p:sp>
         <p:nvSpPr>
-          <p:cNvPr id="45" name="Shape 32"/>
+          <p:cNvPr id="46" name="Shape 33"/>
           <p:cNvSpPr/>
           <p:nvPr/>
         </p:nvSpPr>
@@ -5668,7 +5746,7 @@
       </p:sp>
       <p:pic>
         <p:nvPicPr>
-          <p:cNvPr id="46" name="Image 11" descr="preencoded.png">    </p:cNvPr>
+          <p:cNvPr id="47" name="Image 11" descr="preencoded.png">    </p:cNvPr>
           <p:cNvPicPr>
             <a:picLocks noChangeAspect="1"/>
           </p:cNvPicPr>
@@ -5692,7 +5770,7 @@
       </p:pic>
       <p:sp>
         <p:nvSpPr>
-          <p:cNvPr id="47" name="Text 33"/>
+          <p:cNvPr id="48" name="Text 34"/>
           <p:cNvSpPr txBox="1"/>
           <p:nvPr/>
         </p:nvSpPr>
@@ -5731,7 +5809,7 @@
       </p:sp>
       <p:sp>
         <p:nvSpPr>
-          <p:cNvPr id="48" name="Shape 34"/>
+          <p:cNvPr id="49" name="Shape 35"/>
           <p:cNvSpPr/>
           <p:nvPr/>
         </p:nvSpPr>
@@ -5758,7 +5836,7 @@
       </p:sp>
       <p:pic>
         <p:nvPicPr>
-          <p:cNvPr id="49" name="Image 12" descr="img/tablet_r.png">    </p:cNvPr>
+          <p:cNvPr id="50" name="Image 12" descr="img/tablet_r.png">    </p:cNvPr>
           <p:cNvPicPr>
             <a:picLocks noChangeAspect="1"/>
           </p:cNvPicPr>
@@ -5782,7 +5860,7 @@
       </p:pic>
       <p:sp>
         <p:nvSpPr>
-          <p:cNvPr id="50" name="Text 35"/>
+          <p:cNvPr id="51" name="Text 36"/>
           <p:cNvSpPr txBox="1"/>
           <p:nvPr/>
         </p:nvSpPr>
@@ -5821,7 +5899,7 @@
       </p:sp>
       <p:sp>
         <p:nvSpPr>
-          <p:cNvPr id="51" name="Text 36"/>
+          <p:cNvPr id="52" name="Text 37"/>
           <p:cNvSpPr txBox="1"/>
           <p:nvPr/>
         </p:nvSpPr>
@@ -5860,7 +5938,7 @@
       </p:sp>
       <p:sp>
         <p:nvSpPr>
-          <p:cNvPr id="52" name="Text 37"/>
+          <p:cNvPr id="53" name="Text 38"/>
           <p:cNvSpPr txBox="1"/>
           <p:nvPr/>
         </p:nvSpPr>
@@ -5899,7 +5977,7 @@
       </p:sp>
       <p:sp>
         <p:nvSpPr>
-          <p:cNvPr id="53" name="Text 38"/>
+          <p:cNvPr id="54" name="Text 39"/>
           <p:cNvSpPr txBox="1"/>
           <p:nvPr/>
         </p:nvSpPr>
@@ -5938,7 +6016,7 @@
       </p:sp>
       <p:sp>
         <p:nvSpPr>
-          <p:cNvPr id="54" name="Shape 39"/>
+          <p:cNvPr id="55" name="Shape 40"/>
           <p:cNvSpPr/>
           <p:nvPr/>
         </p:nvSpPr>
@@ -5961,7 +6039,7 @@
       </p:sp>
       <p:sp>
         <p:nvSpPr>
-          <p:cNvPr id="55" name="Text 40"/>
+          <p:cNvPr id="56" name="Text 41"/>
           <p:cNvSpPr txBox="1"/>
           <p:nvPr/>
         </p:nvSpPr>
@@ -6000,7 +6078,7 @@
       </p:sp>
       <p:sp>
         <p:nvSpPr>
-          <p:cNvPr id="56" name="Text 41"/>
+          <p:cNvPr id="57" name="Text 42"/>
           <p:cNvSpPr txBox="1"/>
           <p:nvPr/>
         </p:nvSpPr>
@@ -6077,8 +6155,8 @@
         </p:nvSpPr>
         <p:spPr>
           <a:xfrm>
-            <a:off x="548640" y="6473952"/>
-            <a:ext cx="6400800" cy="201168"/>
+            <a:off x="548640" y="6565392"/>
+            <a:ext cx="6400800" cy="182880"/>
           </a:xfrm>
           <a:prstGeom prst="rect">
             <a:avLst/>
@@ -6116,8 +6194,8 @@
         </p:nvSpPr>
         <p:spPr>
           <a:xfrm>
-            <a:off x="10543032" y="6473952"/>
-            <a:ext cx="1097280" cy="201168"/>
+            <a:off x="10543032" y="6565392"/>
+            <a:ext cx="1097280" cy="182880"/>
           </a:xfrm>
           <a:prstGeom prst="rect">
             <a:avLst/>
@@ -6246,7 +6324,7 @@
                 <a:ea typeface="Arial" pitchFamily="34" charset="-122"/>
                 <a:cs typeface="Arial" pitchFamily="34" charset="-120"/>
               </a:rPr>
-              <a:t>955 подопечных ежедневно и помощь за 1–2 дня</a:t>
+              <a:t>955* подопечных ежедневно и помощь за 1–2 дня</a:t>
             </a:r>
             <a:endParaRPr lang="en-US" sz="3000" dirty="0"/>
           </a:p>
@@ -6254,7 +6332,46 @@
       </p:sp>
       <p:sp>
         <p:nvSpPr>
-          <p:cNvPr id="7" name="Shape 5"/>
+          <p:cNvPr id="7" name="Text 5"/>
+          <p:cNvSpPr txBox="1"/>
+          <p:nvPr/>
+        </p:nvSpPr>
+        <p:spPr>
+          <a:xfrm>
+            <a:off x="548640" y="6355080"/>
+            <a:ext cx="11091672" cy="182880"/>
+          </a:xfrm>
+          <a:prstGeom prst="rect">
+            <a:avLst/>
+          </a:prstGeom>
+          <a:noFill/>
+          <a:ln/>
+        </p:spPr>
+        <p:txBody>
+          <a:bodyPr wrap="square" lIns="0" tIns="0" rIns="0" bIns="0" rtlCol="0" anchor="t"/>
+          <a:lstStyle/>
+          <a:p>
+            <a:pPr indent="0" marL="0">
+              <a:buNone/>
+            </a:pPr>
+            <a:r>
+              <a:rPr lang="en-US" sz="850" i="1" dirty="0">
+                <a:solidFill>
+                  <a:srgbClr val="7A7A7A"/>
+                </a:solidFill>
+                <a:latin typeface="Arial" pitchFamily="34" charset="0"/>
+                <a:ea typeface="Arial" pitchFamily="34" charset="-122"/>
+                <a:cs typeface="Arial" pitchFamily="34" charset="-120"/>
+              </a:rPr>
+              <a:t>* Показатели группы организаций «Содействие»: АНО ЦСО «Содействие», АНО РЦСП «Содействие», АНО ПЦСП «Содействие» — единая система долговременного ухода</a:t>
+            </a:r>
+            <a:endParaRPr lang="en-US" sz="850" dirty="0"/>
+          </a:p>
+        </p:txBody>
+      </p:sp>
+      <p:sp>
+        <p:nvSpPr>
+          <p:cNvPr id="8" name="Shape 6"/>
           <p:cNvSpPr/>
           <p:nvPr/>
         </p:nvSpPr>
@@ -6288,7 +6405,7 @@
       </p:sp>
       <p:sp>
         <p:nvSpPr>
-          <p:cNvPr id="8" name="Text 6"/>
+          <p:cNvPr id="9" name="Text 7"/>
           <p:cNvSpPr txBox="1"/>
           <p:nvPr/>
         </p:nvSpPr>
@@ -6319,7 +6436,7 @@
                 <a:ea typeface="Arial" pitchFamily="34" charset="-122"/>
                 <a:cs typeface="Arial" pitchFamily="34" charset="-120"/>
               </a:rPr>
-              <a:t>Подопечные на обслуживании, чел.</a:t>
+              <a:t>Подопечные на обслуживании*, чел.</a:t>
             </a:r>
             <a:endParaRPr lang="en-US" sz="1200" dirty="0"/>
           </a:p>
@@ -6327,7 +6444,7 @@
       </p:sp>
       <p:graphicFrame>
         <p:nvGraphicFramePr>
-          <p:cNvPr id="9" name="Chart 0" descr=""/>
+          <p:cNvPr id="10" name="Chart 0" descr=""/>
           <p:cNvGraphicFramePr/>
           <p:nvPr/>
         </p:nvGraphicFramePr>
@@ -6343,7 +6460,7 @@
       </p:graphicFrame>
       <p:sp>
         <p:nvSpPr>
-          <p:cNvPr id="10" name="Shape 7"/>
+          <p:cNvPr id="11" name="Shape 8"/>
           <p:cNvSpPr/>
           <p:nvPr/>
         </p:nvSpPr>
@@ -6377,7 +6494,7 @@
       </p:sp>
       <p:sp>
         <p:nvSpPr>
-          <p:cNvPr id="11" name="Shape 8"/>
+          <p:cNvPr id="12" name="Shape 9"/>
           <p:cNvSpPr/>
           <p:nvPr/>
         </p:nvSpPr>
@@ -6402,7 +6519,7 @@
       </p:sp>
       <p:pic>
         <p:nvPicPr>
-          <p:cNvPr id="12" name="Image 0" descr="preencoded.png">    </p:cNvPr>
+          <p:cNvPr id="13" name="Image 0" descr="preencoded.png">    </p:cNvPr>
           <p:cNvPicPr>
             <a:picLocks noChangeAspect="1"/>
           </p:cNvPicPr>
@@ -6426,7 +6543,7 @@
       </p:pic>
       <p:sp>
         <p:nvSpPr>
-          <p:cNvPr id="13" name="Text 9"/>
+          <p:cNvPr id="14" name="Text 10"/>
           <p:cNvSpPr txBox="1"/>
           <p:nvPr/>
         </p:nvSpPr>
@@ -6457,7 +6574,7 @@
                 <a:ea typeface="Arial" pitchFamily="34" charset="-122"/>
                 <a:cs typeface="Arial" pitchFamily="34" charset="-120"/>
               </a:rPr>
-              <a:t>902</a:t>
+              <a:t>902*</a:t>
             </a:r>
             <a:endParaRPr lang="en-US" sz="3000" dirty="0"/>
           </a:p>
@@ -6465,7 +6582,7 @@
       </p:sp>
       <p:sp>
         <p:nvSpPr>
-          <p:cNvPr id="14" name="Text 10"/>
+          <p:cNvPr id="15" name="Text 11"/>
           <p:cNvSpPr txBox="1"/>
           <p:nvPr/>
         </p:nvSpPr>
@@ -6504,7 +6621,7 @@
       </p:sp>
       <p:sp>
         <p:nvSpPr>
-          <p:cNvPr id="15" name="Shape 11"/>
+          <p:cNvPr id="16" name="Shape 12"/>
           <p:cNvSpPr/>
           <p:nvPr/>
         </p:nvSpPr>
@@ -6538,7 +6655,7 @@
       </p:sp>
       <p:sp>
         <p:nvSpPr>
-          <p:cNvPr id="16" name="Shape 12"/>
+          <p:cNvPr id="17" name="Shape 13"/>
           <p:cNvSpPr/>
           <p:nvPr/>
         </p:nvSpPr>
@@ -6563,7 +6680,7 @@
       </p:sp>
       <p:pic>
         <p:nvPicPr>
-          <p:cNvPr id="17" name="Image 1" descr="preencoded.png">    </p:cNvPr>
+          <p:cNvPr id="18" name="Image 1" descr="preencoded.png">    </p:cNvPr>
           <p:cNvPicPr>
             <a:picLocks noChangeAspect="1"/>
           </p:cNvPicPr>
@@ -6587,7 +6704,7 @@
       </p:pic>
       <p:sp>
         <p:nvSpPr>
-          <p:cNvPr id="18" name="Text 13"/>
+          <p:cNvPr id="19" name="Text 14"/>
           <p:cNvSpPr txBox="1"/>
           <p:nvPr/>
         </p:nvSpPr>
@@ -6618,7 +6735,7 @@
                 <a:ea typeface="Arial" pitchFamily="34" charset="-122"/>
                 <a:cs typeface="Arial" pitchFamily="34" charset="-120"/>
               </a:rPr>
-              <a:t>53</a:t>
+              <a:t>53*</a:t>
             </a:r>
             <a:endParaRPr lang="en-US" sz="3000" dirty="0"/>
           </a:p>
@@ -6626,7 +6743,7 @@
       </p:sp>
       <p:sp>
         <p:nvSpPr>
-          <p:cNvPr id="19" name="Text 14"/>
+          <p:cNvPr id="20" name="Text 15"/>
           <p:cNvSpPr txBox="1"/>
           <p:nvPr/>
         </p:nvSpPr>
@@ -6665,7 +6782,7 @@
       </p:sp>
       <p:sp>
         <p:nvSpPr>
-          <p:cNvPr id="20" name="Shape 15"/>
+          <p:cNvPr id="21" name="Shape 16"/>
           <p:cNvSpPr/>
           <p:nvPr/>
         </p:nvSpPr>
@@ -6699,7 +6816,7 @@
       </p:sp>
       <p:sp>
         <p:nvSpPr>
-          <p:cNvPr id="21" name="Shape 16"/>
+          <p:cNvPr id="22" name="Shape 17"/>
           <p:cNvSpPr/>
           <p:nvPr/>
         </p:nvSpPr>
@@ -6724,7 +6841,7 @@
       </p:sp>
       <p:pic>
         <p:nvPicPr>
-          <p:cNvPr id="22" name="Image 2" descr="preencoded.png">    </p:cNvPr>
+          <p:cNvPr id="23" name="Image 2" descr="preencoded.png">    </p:cNvPr>
           <p:cNvPicPr>
             <a:picLocks noChangeAspect="1"/>
           </p:cNvPicPr>
@@ -6748,7 +6865,7 @@
       </p:pic>
       <p:sp>
         <p:nvSpPr>
-          <p:cNvPr id="23" name="Text 17"/>
+          <p:cNvPr id="24" name="Text 18"/>
           <p:cNvSpPr txBox="1"/>
           <p:nvPr/>
         </p:nvSpPr>
@@ -6779,7 +6896,7 @@
                 <a:ea typeface="Arial" pitchFamily="34" charset="-122"/>
                 <a:cs typeface="Arial" pitchFamily="34" charset="-120"/>
               </a:rPr>
-              <a:t>1 млн+</a:t>
+              <a:t>1 млн+*</a:t>
             </a:r>
             <a:endParaRPr lang="en-US" sz="3000" dirty="0"/>
           </a:p>
@@ -6787,7 +6904,7 @@
       </p:sp>
       <p:sp>
         <p:nvSpPr>
-          <p:cNvPr id="24" name="Text 18"/>
+          <p:cNvPr id="25" name="Text 19"/>
           <p:cNvSpPr txBox="1"/>
           <p:nvPr/>
         </p:nvSpPr>
@@ -6826,7 +6943,7 @@
       </p:sp>
       <p:sp>
         <p:nvSpPr>
-          <p:cNvPr id="25" name="Shape 19"/>
+          <p:cNvPr id="26" name="Shape 20"/>
           <p:cNvSpPr/>
           <p:nvPr/>
         </p:nvSpPr>
@@ -6860,7 +6977,7 @@
       </p:sp>
       <p:sp>
         <p:nvSpPr>
-          <p:cNvPr id="26" name="Shape 20"/>
+          <p:cNvPr id="27" name="Shape 21"/>
           <p:cNvSpPr/>
           <p:nvPr/>
         </p:nvSpPr>
@@ -6885,7 +7002,7 @@
       </p:sp>
       <p:pic>
         <p:nvPicPr>
-          <p:cNvPr id="27" name="Image 3" descr="preencoded.png">    </p:cNvPr>
+          <p:cNvPr id="28" name="Image 3" descr="preencoded.png">    </p:cNvPr>
           <p:cNvPicPr>
             <a:picLocks noChangeAspect="1"/>
           </p:cNvPicPr>
@@ -6909,7 +7026,7 @@
       </p:pic>
       <p:sp>
         <p:nvSpPr>
-          <p:cNvPr id="28" name="Text 21"/>
+          <p:cNvPr id="29" name="Text 22"/>
           <p:cNvSpPr txBox="1"/>
           <p:nvPr/>
         </p:nvSpPr>
@@ -6940,7 +7057,7 @@
                 <a:ea typeface="Arial" pitchFamily="34" charset="-122"/>
                 <a:cs typeface="Arial" pitchFamily="34" charset="-120"/>
               </a:rPr>
-              <a:t>1 500+</a:t>
+              <a:t>1 500+*</a:t>
             </a:r>
             <a:endParaRPr lang="en-US" sz="3000" dirty="0"/>
           </a:p>
@@ -6948,7 +7065,7 @@
       </p:sp>
       <p:sp>
         <p:nvSpPr>
-          <p:cNvPr id="29" name="Text 22"/>
+          <p:cNvPr id="30" name="Text 23"/>
           <p:cNvSpPr txBox="1"/>
           <p:nvPr/>
         </p:nvSpPr>
@@ -6987,7 +7104,7 @@
       </p:sp>
       <p:sp>
         <p:nvSpPr>
-          <p:cNvPr id="30" name="Shape 23"/>
+          <p:cNvPr id="31" name="Shape 24"/>
           <p:cNvSpPr/>
           <p:nvPr/>
         </p:nvSpPr>
@@ -7014,7 +7131,7 @@
       </p:sp>
       <p:sp>
         <p:nvSpPr>
-          <p:cNvPr id="31" name="Text 24"/>
+          <p:cNvPr id="32" name="Text 25"/>
           <p:cNvSpPr txBox="1"/>
           <p:nvPr/>
         </p:nvSpPr>
@@ -7053,7 +7170,7 @@
       </p:sp>
       <p:pic>
         <p:nvPicPr>
-          <p:cNvPr id="32" name="Image 4" descr="preencoded.png">    </p:cNvPr>
+          <p:cNvPr id="33" name="Image 4" descr="preencoded.png">    </p:cNvPr>
           <p:cNvPicPr>
             <a:picLocks noChangeAspect="1"/>
           </p:cNvPicPr>
@@ -7077,7 +7194,7 @@
       </p:pic>
       <p:sp>
         <p:nvSpPr>
-          <p:cNvPr id="33" name="Text 25"/>
+          <p:cNvPr id="34" name="Text 26"/>
           <p:cNvSpPr txBox="1"/>
           <p:nvPr/>
         </p:nvSpPr>
@@ -7116,7 +7233,7 @@
       </p:sp>
       <p:sp>
         <p:nvSpPr>
-          <p:cNvPr id="34" name="Text 26"/>
+          <p:cNvPr id="35" name="Text 27"/>
           <p:cNvSpPr txBox="1"/>
           <p:nvPr/>
         </p:nvSpPr>
@@ -7155,7 +7272,7 @@
       </p:sp>
       <p:pic>
         <p:nvPicPr>
-          <p:cNvPr id="35" name="Image 5" descr="preencoded.png">    </p:cNvPr>
+          <p:cNvPr id="36" name="Image 5" descr="preencoded.png">    </p:cNvPr>
           <p:cNvPicPr>
             <a:picLocks noChangeAspect="1"/>
           </p:cNvPicPr>
@@ -7179,7 +7296,7 @@
       </p:pic>
       <p:sp>
         <p:nvSpPr>
-          <p:cNvPr id="36" name="Text 27"/>
+          <p:cNvPr id="37" name="Text 28"/>
           <p:cNvSpPr txBox="1"/>
           <p:nvPr/>
         </p:nvSpPr>
@@ -7218,7 +7335,7 @@
       </p:sp>
       <p:sp>
         <p:nvSpPr>
-          <p:cNvPr id="37" name="Text 28"/>
+          <p:cNvPr id="38" name="Text 29"/>
           <p:cNvSpPr txBox="1"/>
           <p:nvPr/>
         </p:nvSpPr>
@@ -7257,7 +7374,7 @@
       </p:sp>
       <p:pic>
         <p:nvPicPr>
-          <p:cNvPr id="38" name="Image 6" descr="preencoded.png">    </p:cNvPr>
+          <p:cNvPr id="39" name="Image 6" descr="preencoded.png">    </p:cNvPr>
           <p:cNvPicPr>
             <a:picLocks noChangeAspect="1"/>
           </p:cNvPicPr>
@@ -7281,7 +7398,7 @@
       </p:pic>
       <p:sp>
         <p:nvSpPr>
-          <p:cNvPr id="39" name="Text 29"/>
+          <p:cNvPr id="40" name="Text 30"/>
           <p:cNvSpPr txBox="1"/>
           <p:nvPr/>
         </p:nvSpPr>
@@ -7312,7 +7429,7 @@
                 <a:ea typeface="Arial" pitchFamily="34" charset="-122"/>
                 <a:cs typeface="Arial" pitchFamily="34" charset="-120"/>
               </a:rPr>
-              <a:t>200+ родственников</a:t>
+              <a:t>200+ родственников*</a:t>
             </a:r>
             <a:endParaRPr lang="en-US" sz="1250" dirty="0"/>
           </a:p>
@@ -7320,7 +7437,7 @@
       </p:sp>
       <p:sp>
         <p:nvSpPr>
-          <p:cNvPr id="40" name="Text 30"/>
+          <p:cNvPr id="41" name="Text 31"/>
           <p:cNvSpPr txBox="1"/>
           <p:nvPr/>
         </p:nvSpPr>
@@ -7359,7 +7476,7 @@
       </p:sp>
       <p:pic>
         <p:nvPicPr>
-          <p:cNvPr id="41" name="Image 7" descr="preencoded.png">    </p:cNvPr>
+          <p:cNvPr id="42" name="Image 7" descr="preencoded.png">    </p:cNvPr>
           <p:cNvPicPr>
             <a:picLocks noChangeAspect="1"/>
           </p:cNvPicPr>
@@ -7383,7 +7500,7 @@
       </p:pic>
       <p:sp>
         <p:nvSpPr>
-          <p:cNvPr id="42" name="Text 31"/>
+          <p:cNvPr id="43" name="Text 32"/>
           <p:cNvSpPr txBox="1"/>
           <p:nvPr/>
         </p:nvSpPr>
@@ -7422,7 +7539,7 @@
       </p:sp>
       <p:sp>
         <p:nvSpPr>
-          <p:cNvPr id="43" name="Text 32"/>
+          <p:cNvPr id="44" name="Text 33"/>
           <p:cNvSpPr txBox="1"/>
           <p:nvPr/>
         </p:nvSpPr>
@@ -7461,7 +7578,7 @@
       </p:sp>
       <p:sp>
         <p:nvSpPr>
-          <p:cNvPr id="44" name="Shape 33"/>
+          <p:cNvPr id="45" name="Shape 34"/>
           <p:cNvSpPr/>
           <p:nvPr/>
         </p:nvSpPr>
@@ -7495,7 +7612,7 @@
       </p:sp>
       <p:sp>
         <p:nvSpPr>
-          <p:cNvPr id="45" name="Text 34"/>
+          <p:cNvPr id="46" name="Text 35"/>
           <p:cNvSpPr txBox="1"/>
           <p:nvPr/>
         </p:nvSpPr>
@@ -7534,7 +7651,7 @@
       </p:sp>
       <p:sp>
         <p:nvSpPr>
-          <p:cNvPr id="46" name="Shape 35"/>
+          <p:cNvPr id="47" name="Shape 36"/>
           <p:cNvSpPr/>
           <p:nvPr/>
         </p:nvSpPr>
@@ -7561,7 +7678,7 @@
       </p:sp>
       <p:sp>
         <p:nvSpPr>
-          <p:cNvPr id="47" name="Text 36"/>
+          <p:cNvPr id="48" name="Text 37"/>
           <p:cNvSpPr txBox="1"/>
           <p:nvPr/>
         </p:nvSpPr>
@@ -7600,7 +7717,7 @@
       </p:sp>
       <p:sp>
         <p:nvSpPr>
-          <p:cNvPr id="48" name="Text 37"/>
+          <p:cNvPr id="49" name="Text 38"/>
           <p:cNvSpPr txBox="1"/>
           <p:nvPr/>
         </p:nvSpPr>
@@ -7639,7 +7756,7 @@
       </p:sp>
       <p:sp>
         <p:nvSpPr>
-          <p:cNvPr id="49" name="Shape 38"/>
+          <p:cNvPr id="50" name="Shape 39"/>
           <p:cNvSpPr/>
           <p:nvPr/>
         </p:nvSpPr>
@@ -7666,7 +7783,7 @@
       </p:sp>
       <p:sp>
         <p:nvSpPr>
-          <p:cNvPr id="50" name="Text 39"/>
+          <p:cNvPr id="51" name="Text 40"/>
           <p:cNvSpPr txBox="1"/>
           <p:nvPr/>
         </p:nvSpPr>
@@ -7705,7 +7822,7 @@
       </p:sp>
       <p:sp>
         <p:nvSpPr>
-          <p:cNvPr id="51" name="Text 40"/>
+          <p:cNvPr id="52" name="Text 41"/>
           <p:cNvSpPr txBox="1"/>
           <p:nvPr/>
         </p:nvSpPr>
@@ -7744,7 +7861,7 @@
       </p:sp>
       <p:sp>
         <p:nvSpPr>
-          <p:cNvPr id="52" name="Shape 41"/>
+          <p:cNvPr id="53" name="Shape 42"/>
           <p:cNvSpPr/>
           <p:nvPr/>
         </p:nvSpPr>
@@ -7771,7 +7888,7 @@
       </p:sp>
       <p:sp>
         <p:nvSpPr>
-          <p:cNvPr id="53" name="Text 42"/>
+          <p:cNvPr id="54" name="Text 43"/>
           <p:cNvSpPr txBox="1"/>
           <p:nvPr/>
         </p:nvSpPr>
@@ -7810,7 +7927,7 @@
       </p:sp>
       <p:sp>
         <p:nvSpPr>
-          <p:cNvPr id="54" name="Text 43"/>
+          <p:cNvPr id="55" name="Text 44"/>
           <p:cNvSpPr txBox="1"/>
           <p:nvPr/>
         </p:nvSpPr>
@@ -7849,7 +7966,7 @@
       </p:sp>
       <p:sp>
         <p:nvSpPr>
-          <p:cNvPr id="55" name="Shape 44"/>
+          <p:cNvPr id="56" name="Shape 45"/>
           <p:cNvSpPr/>
           <p:nvPr/>
         </p:nvSpPr>
@@ -7876,7 +7993,7 @@
       </p:sp>
       <p:sp>
         <p:nvSpPr>
-          <p:cNvPr id="56" name="Text 45"/>
+          <p:cNvPr id="57" name="Text 46"/>
           <p:cNvSpPr txBox="1"/>
           <p:nvPr/>
         </p:nvSpPr>
@@ -7915,7 +8032,7 @@
       </p:sp>
       <p:sp>
         <p:nvSpPr>
-          <p:cNvPr id="57" name="Text 46"/>
+          <p:cNvPr id="58" name="Text 47"/>
           <p:cNvSpPr txBox="1"/>
           <p:nvPr/>
         </p:nvSpPr>
@@ -7954,7 +8071,7 @@
       </p:sp>
       <p:sp>
         <p:nvSpPr>
-          <p:cNvPr id="58" name="Shape 47"/>
+          <p:cNvPr id="59" name="Shape 48"/>
           <p:cNvSpPr/>
           <p:nvPr/>
         </p:nvSpPr>
@@ -7981,7 +8098,7 @@
       </p:sp>
       <p:sp>
         <p:nvSpPr>
-          <p:cNvPr id="59" name="Text 48"/>
+          <p:cNvPr id="60" name="Text 49"/>
           <p:cNvSpPr txBox="1"/>
           <p:nvPr/>
         </p:nvSpPr>
@@ -8020,7 +8137,7 @@
       </p:sp>
       <p:sp>
         <p:nvSpPr>
-          <p:cNvPr id="60" name="Text 49"/>
+          <p:cNvPr id="61" name="Text 50"/>
           <p:cNvSpPr txBox="1"/>
           <p:nvPr/>
         </p:nvSpPr>
@@ -8097,8 +8214,8 @@
         </p:nvSpPr>
         <p:spPr>
           <a:xfrm>
-            <a:off x="548640" y="6473952"/>
-            <a:ext cx="6400800" cy="201168"/>
+            <a:off x="548640" y="6565392"/>
+            <a:ext cx="6400800" cy="182880"/>
           </a:xfrm>
           <a:prstGeom prst="rect">
             <a:avLst/>
@@ -8136,8 +8253,8 @@
         </p:nvSpPr>
         <p:spPr>
           <a:xfrm>
-            <a:off x="10543032" y="6473952"/>
-            <a:ext cx="1097280" cy="201168"/>
+            <a:off x="10543032" y="6565392"/>
+            <a:ext cx="1097280" cy="182880"/>
           </a:xfrm>
           <a:prstGeom prst="rect">
             <a:avLst/>
@@ -8274,7 +8391,46 @@
       </p:sp>
       <p:sp>
         <p:nvSpPr>
-          <p:cNvPr id="7" name="Shape 5"/>
+          <p:cNvPr id="7" name="Text 5"/>
+          <p:cNvSpPr txBox="1"/>
+          <p:nvPr/>
+        </p:nvSpPr>
+        <p:spPr>
+          <a:xfrm>
+            <a:off x="548640" y="6355080"/>
+            <a:ext cx="11091672" cy="182880"/>
+          </a:xfrm>
+          <a:prstGeom prst="rect">
+            <a:avLst/>
+          </a:prstGeom>
+          <a:noFill/>
+          <a:ln/>
+        </p:spPr>
+        <p:txBody>
+          <a:bodyPr wrap="square" lIns="0" tIns="0" rIns="0" bIns="0" rtlCol="0" anchor="t"/>
+          <a:lstStyle/>
+          <a:p>
+            <a:pPr indent="0" marL="0">
+              <a:buNone/>
+            </a:pPr>
+            <a:r>
+              <a:rPr lang="en-US" sz="850" i="1" dirty="0">
+                <a:solidFill>
+                  <a:srgbClr val="7A7A7A"/>
+                </a:solidFill>
+                <a:latin typeface="Arial" pitchFamily="34" charset="0"/>
+                <a:ea typeface="Arial" pitchFamily="34" charset="-122"/>
+                <a:cs typeface="Arial" pitchFamily="34" charset="-120"/>
+              </a:rPr>
+              <a:t>* Показатели группы организаций «Содействие»: АНО ЦСО «Содействие», АНО РЦСП «Содействие», АНО ПЦСП «Содействие» — единая система долговременного ухода</a:t>
+            </a:r>
+            <a:endParaRPr lang="en-US" sz="850" dirty="0"/>
+          </a:p>
+        </p:txBody>
+      </p:sp>
+      <p:sp>
+        <p:nvSpPr>
+          <p:cNvPr id="8" name="Shape 6"/>
           <p:cNvSpPr/>
           <p:nvPr/>
         </p:nvSpPr>
@@ -8308,7 +8464,7 @@
       </p:sp>
       <p:sp>
         <p:nvSpPr>
-          <p:cNvPr id="8" name="Shape 6"/>
+          <p:cNvPr id="9" name="Shape 7"/>
           <p:cNvSpPr/>
           <p:nvPr/>
         </p:nvSpPr>
@@ -8333,7 +8489,7 @@
       </p:sp>
       <p:pic>
         <p:nvPicPr>
-          <p:cNvPr id="9" name="Image 0" descr="preencoded.png">    </p:cNvPr>
+          <p:cNvPr id="10" name="Image 0" descr="preencoded.png">    </p:cNvPr>
           <p:cNvPicPr>
             <a:picLocks noChangeAspect="1"/>
           </p:cNvPicPr>
@@ -8357,7 +8513,7 @@
       </p:pic>
       <p:sp>
         <p:nvSpPr>
-          <p:cNvPr id="10" name="Text 7"/>
+          <p:cNvPr id="11" name="Text 8"/>
           <p:cNvSpPr txBox="1"/>
           <p:nvPr/>
         </p:nvSpPr>
@@ -8388,7 +8544,7 @@
                 <a:ea typeface="Arial" pitchFamily="34" charset="-122"/>
                 <a:cs typeface="Arial" pitchFamily="34" charset="-120"/>
               </a:rPr>
-              <a:t>1 000+</a:t>
+              <a:t>1 000+*</a:t>
             </a:r>
             <a:endParaRPr lang="en-US" sz="3600" dirty="0"/>
           </a:p>
@@ -8396,7 +8552,7 @@
       </p:sp>
       <p:sp>
         <p:nvSpPr>
-          <p:cNvPr id="11" name="Text 8"/>
+          <p:cNvPr id="12" name="Text 9"/>
           <p:cNvSpPr txBox="1"/>
           <p:nvPr/>
         </p:nvSpPr>
@@ -8435,7 +8591,7 @@
       </p:sp>
       <p:sp>
         <p:nvSpPr>
-          <p:cNvPr id="12" name="Text 9"/>
+          <p:cNvPr id="13" name="Text 10"/>
           <p:cNvSpPr txBox="1"/>
           <p:nvPr/>
         </p:nvSpPr>
@@ -8474,7 +8630,7 @@
       </p:sp>
       <p:sp>
         <p:nvSpPr>
-          <p:cNvPr id="13" name="Shape 10"/>
+          <p:cNvPr id="14" name="Shape 11"/>
           <p:cNvSpPr/>
           <p:nvPr/>
         </p:nvSpPr>
@@ -8508,7 +8664,7 @@
       </p:sp>
       <p:sp>
         <p:nvSpPr>
-          <p:cNvPr id="14" name="Shape 11"/>
+          <p:cNvPr id="15" name="Shape 12"/>
           <p:cNvSpPr/>
           <p:nvPr/>
         </p:nvSpPr>
@@ -8533,7 +8689,7 @@
       </p:sp>
       <p:pic>
         <p:nvPicPr>
-          <p:cNvPr id="15" name="Image 1" descr="preencoded.png">    </p:cNvPr>
+          <p:cNvPr id="16" name="Image 1" descr="preencoded.png">    </p:cNvPr>
           <p:cNvPicPr>
             <a:picLocks noChangeAspect="1"/>
           </p:cNvPicPr>
@@ -8557,7 +8713,7 @@
       </p:pic>
       <p:sp>
         <p:nvSpPr>
-          <p:cNvPr id="16" name="Text 12"/>
+          <p:cNvPr id="17" name="Text 13"/>
           <p:cNvSpPr txBox="1"/>
           <p:nvPr/>
         </p:nvSpPr>
@@ -8588,7 +8744,7 @@
                 <a:ea typeface="Arial" pitchFamily="34" charset="-122"/>
                 <a:cs typeface="Arial" pitchFamily="34" charset="-120"/>
               </a:rPr>
-              <a:t>200+</a:t>
+              <a:t>200+*</a:t>
             </a:r>
             <a:endParaRPr lang="en-US" sz="3600" dirty="0"/>
           </a:p>
@@ -8596,7 +8752,7 @@
       </p:sp>
       <p:sp>
         <p:nvSpPr>
-          <p:cNvPr id="17" name="Text 13"/>
+          <p:cNvPr id="18" name="Text 14"/>
           <p:cNvSpPr txBox="1"/>
           <p:nvPr/>
         </p:nvSpPr>
@@ -8635,7 +8791,7 @@
       </p:sp>
       <p:sp>
         <p:nvSpPr>
-          <p:cNvPr id="18" name="Text 14"/>
+          <p:cNvPr id="19" name="Text 15"/>
           <p:cNvSpPr txBox="1"/>
           <p:nvPr/>
         </p:nvSpPr>
@@ -8674,7 +8830,7 @@
       </p:sp>
       <p:sp>
         <p:nvSpPr>
-          <p:cNvPr id="19" name="Shape 15"/>
+          <p:cNvPr id="20" name="Shape 16"/>
           <p:cNvSpPr/>
           <p:nvPr/>
         </p:nvSpPr>
@@ -8708,7 +8864,7 @@
       </p:sp>
       <p:sp>
         <p:nvSpPr>
-          <p:cNvPr id="20" name="Shape 16"/>
+          <p:cNvPr id="21" name="Shape 17"/>
           <p:cNvSpPr/>
           <p:nvPr/>
         </p:nvSpPr>
@@ -8733,7 +8889,7 @@
       </p:sp>
       <p:pic>
         <p:nvPicPr>
-          <p:cNvPr id="21" name="Image 2" descr="preencoded.png">    </p:cNvPr>
+          <p:cNvPr id="22" name="Image 2" descr="preencoded.png">    </p:cNvPr>
           <p:cNvPicPr>
             <a:picLocks noChangeAspect="1"/>
           </p:cNvPicPr>
@@ -8757,7 +8913,7 @@
       </p:pic>
       <p:sp>
         <p:nvSpPr>
-          <p:cNvPr id="22" name="Text 17"/>
+          <p:cNvPr id="23" name="Text 18"/>
           <p:cNvSpPr txBox="1"/>
           <p:nvPr/>
         </p:nvSpPr>
@@ -8788,7 +8944,7 @@
                 <a:ea typeface="Arial" pitchFamily="34" charset="-122"/>
                 <a:cs typeface="Arial" pitchFamily="34" charset="-120"/>
               </a:rPr>
-              <a:t>23</a:t>
+              <a:t>23*</a:t>
             </a:r>
             <a:endParaRPr lang="en-US" sz="3600" dirty="0"/>
           </a:p>
@@ -8796,7 +8952,7 @@
       </p:sp>
       <p:sp>
         <p:nvSpPr>
-          <p:cNvPr id="23" name="Text 18"/>
+          <p:cNvPr id="24" name="Text 19"/>
           <p:cNvSpPr txBox="1"/>
           <p:nvPr/>
         </p:nvSpPr>
@@ -8835,7 +8991,7 @@
       </p:sp>
       <p:sp>
         <p:nvSpPr>
-          <p:cNvPr id="24" name="Text 19"/>
+          <p:cNvPr id="25" name="Text 20"/>
           <p:cNvSpPr txBox="1"/>
           <p:nvPr/>
         </p:nvSpPr>
@@ -8874,7 +9030,7 @@
       </p:sp>
       <p:sp>
         <p:nvSpPr>
-          <p:cNvPr id="25" name="Shape 20"/>
+          <p:cNvPr id="26" name="Shape 21"/>
           <p:cNvSpPr/>
           <p:nvPr/>
         </p:nvSpPr>
@@ -8908,7 +9064,7 @@
       </p:sp>
       <p:sp>
         <p:nvSpPr>
-          <p:cNvPr id="26" name="Shape 21"/>
+          <p:cNvPr id="27" name="Shape 22"/>
           <p:cNvSpPr/>
           <p:nvPr/>
         </p:nvSpPr>
@@ -8933,7 +9089,7 @@
       </p:sp>
       <p:pic>
         <p:nvPicPr>
-          <p:cNvPr id="27" name="Image 3" descr="preencoded.png">    </p:cNvPr>
+          <p:cNvPr id="28" name="Image 3" descr="preencoded.png">    </p:cNvPr>
           <p:cNvPicPr>
             <a:picLocks noChangeAspect="1"/>
           </p:cNvPicPr>
@@ -8957,7 +9113,7 @@
       </p:pic>
       <p:sp>
         <p:nvSpPr>
-          <p:cNvPr id="28" name="Text 22"/>
+          <p:cNvPr id="29" name="Text 23"/>
           <p:cNvSpPr txBox="1"/>
           <p:nvPr/>
         </p:nvSpPr>
@@ -8988,7 +9144,7 @@
                 <a:ea typeface="Arial" pitchFamily="34" charset="-122"/>
                 <a:cs typeface="Arial" pitchFamily="34" charset="-120"/>
               </a:rPr>
-              <a:t>955</a:t>
+              <a:t>955*</a:t>
             </a:r>
             <a:endParaRPr lang="en-US" sz="3600" dirty="0"/>
           </a:p>
@@ -8996,7 +9152,7 @@
       </p:sp>
       <p:sp>
         <p:nvSpPr>
-          <p:cNvPr id="29" name="Text 23"/>
+          <p:cNvPr id="30" name="Text 24"/>
           <p:cNvSpPr txBox="1"/>
           <p:nvPr/>
         </p:nvSpPr>
@@ -9035,7 +9191,7 @@
       </p:sp>
       <p:sp>
         <p:nvSpPr>
-          <p:cNvPr id="30" name="Text 24"/>
+          <p:cNvPr id="31" name="Text 25"/>
           <p:cNvSpPr txBox="1"/>
           <p:nvPr/>
         </p:nvSpPr>
@@ -9074,7 +9230,7 @@
       </p:sp>
       <p:sp>
         <p:nvSpPr>
-          <p:cNvPr id="31" name="Text 25"/>
+          <p:cNvPr id="32" name="Text 26"/>
           <p:cNvSpPr txBox="1"/>
           <p:nvPr/>
         </p:nvSpPr>
@@ -9113,7 +9269,7 @@
       </p:sp>
       <p:sp>
         <p:nvSpPr>
-          <p:cNvPr id="32" name="Shape 26"/>
+          <p:cNvPr id="33" name="Shape 27"/>
           <p:cNvSpPr/>
           <p:nvPr/>
         </p:nvSpPr>
@@ -9140,7 +9296,7 @@
       </p:sp>
       <p:sp>
         <p:nvSpPr>
-          <p:cNvPr id="33" name="Text 27"/>
+          <p:cNvPr id="34" name="Text 28"/>
           <p:cNvSpPr txBox="1"/>
           <p:nvPr/>
         </p:nvSpPr>
@@ -9179,7 +9335,7 @@
       </p:sp>
       <p:sp>
         <p:nvSpPr>
-          <p:cNvPr id="34" name="Text 28"/>
+          <p:cNvPr id="35" name="Text 29"/>
           <p:cNvSpPr txBox="1"/>
           <p:nvPr/>
         </p:nvSpPr>
@@ -9218,7 +9374,7 @@
       </p:sp>
       <p:sp>
         <p:nvSpPr>
-          <p:cNvPr id="35" name="Shape 29"/>
+          <p:cNvPr id="36" name="Shape 30"/>
           <p:cNvSpPr/>
           <p:nvPr/>
         </p:nvSpPr>
@@ -9245,7 +9401,7 @@
       </p:sp>
       <p:sp>
         <p:nvSpPr>
-          <p:cNvPr id="36" name="Text 30"/>
+          <p:cNvPr id="37" name="Text 31"/>
           <p:cNvSpPr txBox="1"/>
           <p:nvPr/>
         </p:nvSpPr>
@@ -9284,7 +9440,7 @@
       </p:sp>
       <p:sp>
         <p:nvSpPr>
-          <p:cNvPr id="37" name="Shape 31"/>
+          <p:cNvPr id="38" name="Shape 32"/>
           <p:cNvSpPr/>
           <p:nvPr/>
         </p:nvSpPr>
@@ -9311,7 +9467,7 @@
       </p:sp>
       <p:sp>
         <p:nvSpPr>
-          <p:cNvPr id="38" name="Text 32"/>
+          <p:cNvPr id="39" name="Text 33"/>
           <p:cNvSpPr txBox="1"/>
           <p:nvPr/>
         </p:nvSpPr>
@@ -9350,7 +9506,7 @@
       </p:sp>
       <p:pic>
         <p:nvPicPr>
-          <p:cNvPr id="39" name="Image 4" descr="preencoded.png">    </p:cNvPr>
+          <p:cNvPr id="40" name="Image 4" descr="preencoded.png">    </p:cNvPr>
           <p:cNvPicPr>
             <a:picLocks noChangeAspect="1"/>
           </p:cNvPicPr>
@@ -9374,7 +9530,7 @@
       </p:pic>
       <p:sp>
         <p:nvSpPr>
-          <p:cNvPr id="40" name="Text 33"/>
+          <p:cNvPr id="41" name="Text 34"/>
           <p:cNvSpPr txBox="1"/>
           <p:nvPr/>
         </p:nvSpPr>
@@ -9405,7 +9561,7 @@
                 <a:ea typeface="Arial" pitchFamily="34" charset="-122"/>
                 <a:cs typeface="Arial" pitchFamily="34" charset="-120"/>
               </a:rPr>
-              <a:t>300+</a:t>
+              <a:t>300+*</a:t>
             </a:r>
             <a:endParaRPr lang="en-US" sz="3600" dirty="0"/>
           </a:p>
@@ -9413,7 +9569,7 @@
       </p:sp>
       <p:sp>
         <p:nvSpPr>
-          <p:cNvPr id="41" name="Text 34"/>
+          <p:cNvPr id="42" name="Text 35"/>
           <p:cNvSpPr txBox="1"/>
           <p:nvPr/>
         </p:nvSpPr>
@@ -9452,7 +9608,7 @@
       </p:sp>
       <p:pic>
         <p:nvPicPr>
-          <p:cNvPr id="42" name="Image 5" descr="preencoded.png">    </p:cNvPr>
+          <p:cNvPr id="43" name="Image 5" descr="preencoded.png">    </p:cNvPr>
           <p:cNvPicPr>
             <a:picLocks noChangeAspect="1"/>
           </p:cNvPicPr>
@@ -9476,7 +9632,7 @@
       </p:pic>
       <p:sp>
         <p:nvSpPr>
-          <p:cNvPr id="43" name="Text 35"/>
+          <p:cNvPr id="44" name="Text 36"/>
           <p:cNvSpPr txBox="1"/>
           <p:nvPr/>
         </p:nvSpPr>
@@ -9515,7 +9671,7 @@
       </p:sp>
       <p:sp>
         <p:nvSpPr>
-          <p:cNvPr id="44" name="Text 36"/>
+          <p:cNvPr id="45" name="Text 37"/>
           <p:cNvSpPr txBox="1"/>
           <p:nvPr/>
         </p:nvSpPr>
@@ -9554,7 +9710,7 @@
       </p:sp>
       <p:sp>
         <p:nvSpPr>
-          <p:cNvPr id="45" name="Text 37"/>
+          <p:cNvPr id="46" name="Text 38"/>
           <p:cNvSpPr txBox="1"/>
           <p:nvPr/>
         </p:nvSpPr>
@@ -9631,8 +9787,8 @@
         </p:nvSpPr>
         <p:spPr>
           <a:xfrm>
-            <a:off x="548640" y="6473952"/>
-            <a:ext cx="6400800" cy="201168"/>
+            <a:off x="548640" y="6565392"/>
+            <a:ext cx="6400800" cy="182880"/>
           </a:xfrm>
           <a:prstGeom prst="rect">
             <a:avLst/>
@@ -9670,8 +9826,8 @@
         </p:nvSpPr>
         <p:spPr>
           <a:xfrm>
-            <a:off x="10543032" y="6473952"/>
-            <a:ext cx="1097280" cy="201168"/>
+            <a:off x="10543032" y="6565392"/>
+            <a:ext cx="1097280" cy="182880"/>
           </a:xfrm>
           <a:prstGeom prst="rect">
             <a:avLst/>
@@ -9808,7 +9964,46 @@
       </p:sp>
       <p:sp>
         <p:nvSpPr>
-          <p:cNvPr id="7" name="Shape 5"/>
+          <p:cNvPr id="7" name="Text 5"/>
+          <p:cNvSpPr txBox="1"/>
+          <p:nvPr/>
+        </p:nvSpPr>
+        <p:spPr>
+          <a:xfrm>
+            <a:off x="548640" y="6355080"/>
+            <a:ext cx="11091672" cy="182880"/>
+          </a:xfrm>
+          <a:prstGeom prst="rect">
+            <a:avLst/>
+          </a:prstGeom>
+          <a:noFill/>
+          <a:ln/>
+        </p:spPr>
+        <p:txBody>
+          <a:bodyPr wrap="square" lIns="0" tIns="0" rIns="0" bIns="0" rtlCol="0" anchor="t"/>
+          <a:lstStyle/>
+          <a:p>
+            <a:pPr indent="0" marL="0">
+              <a:buNone/>
+            </a:pPr>
+            <a:r>
+              <a:rPr lang="en-US" sz="850" i="1" dirty="0">
+                <a:solidFill>
+                  <a:srgbClr val="7A7A7A"/>
+                </a:solidFill>
+                <a:latin typeface="Arial" pitchFamily="34" charset="0"/>
+                <a:ea typeface="Arial" pitchFamily="34" charset="-122"/>
+                <a:cs typeface="Arial" pitchFamily="34" charset="-120"/>
+              </a:rPr>
+              <a:t>* Показатели группы организаций «Содействие»: АНО ЦСО «Содействие», АНО РЦСП «Содействие», АНО ПЦСП «Содействие» — единая система долговременного ухода</a:t>
+            </a:r>
+            <a:endParaRPr lang="en-US" sz="850" dirty="0"/>
+          </a:p>
+        </p:txBody>
+      </p:sp>
+      <p:sp>
+        <p:nvSpPr>
+          <p:cNvPr id="8" name="Shape 6"/>
           <p:cNvSpPr/>
           <p:nvPr/>
         </p:nvSpPr>
@@ -9842,7 +10037,7 @@
       </p:sp>
       <p:sp>
         <p:nvSpPr>
-          <p:cNvPr id="8" name="Shape 6"/>
+          <p:cNvPr id="9" name="Shape 7"/>
           <p:cNvSpPr/>
           <p:nvPr/>
         </p:nvSpPr>
@@ -9867,7 +10062,7 @@
       </p:sp>
       <p:pic>
         <p:nvPicPr>
-          <p:cNvPr id="9" name="Image 0" descr="img/c_team5.jpg">    </p:cNvPr>
+          <p:cNvPr id="10" name="Image 0" descr="img/c_team5.jpg">    </p:cNvPr>
           <p:cNvPicPr>
             <a:picLocks noChangeAspect="1"/>
           </p:cNvPicPr>
@@ -9891,7 +10086,7 @@
       </p:pic>
       <p:sp>
         <p:nvSpPr>
-          <p:cNvPr id="10" name="Shape 7"/>
+          <p:cNvPr id="11" name="Shape 8"/>
           <p:cNvSpPr/>
           <p:nvPr/>
         </p:nvSpPr>
@@ -9918,7 +10113,7 @@
       </p:sp>
       <p:sp>
         <p:nvSpPr>
-          <p:cNvPr id="11" name="Text 8"/>
+          <p:cNvPr id="12" name="Text 9"/>
           <p:cNvSpPr txBox="1"/>
           <p:nvPr/>
         </p:nvSpPr>
@@ -9957,7 +10152,7 @@
       </p:sp>
       <p:sp>
         <p:nvSpPr>
-          <p:cNvPr id="12" name="Text 9"/>
+          <p:cNvPr id="13" name="Text 10"/>
           <p:cNvSpPr txBox="1"/>
           <p:nvPr/>
         </p:nvSpPr>
@@ -9996,14 +10191,14 @@
       </p:sp>
       <p:sp>
         <p:nvSpPr>
-          <p:cNvPr id="13" name="Text 10"/>
-          <p:cNvSpPr txBox="1"/>
-          <p:nvPr/>
-        </p:nvSpPr>
-        <p:spPr>
-          <a:xfrm>
-            <a:off x="777240" y="3081528"/>
-            <a:ext cx="3127248" cy="457200"/>
+          <p:cNvPr id="14" name="Text 11"/>
+          <p:cNvSpPr txBox="1"/>
+          <p:nvPr/>
+        </p:nvSpPr>
+        <p:spPr>
+          <a:xfrm>
+            <a:off x="777240" y="3035808"/>
+            <a:ext cx="3172968" cy="548640"/>
           </a:xfrm>
           <a:prstGeom prst="rect">
             <a:avLst/>
@@ -10019,7 +10214,7 @@
               <a:buNone/>
             </a:pPr>
             <a:r>
-              <a:rPr lang="en-US" sz="1100" dirty="0">
+              <a:rPr lang="en-US" sz="1050" dirty="0">
                 <a:solidFill>
                   <a:srgbClr val="5F6B70"/>
                 </a:solidFill>
@@ -10027,15 +10222,15 @@
                 <a:ea typeface="Arial" pitchFamily="34" charset="-122"/>
                 <a:cs typeface="Arial" pitchFamily="34" charset="-120"/>
               </a:rPr>
-              <a:t>Стратегия, развитие и масштабирование; инициатор Sidelka Online</a:t>
-            </a:r>
-            <a:endParaRPr lang="en-US" sz="1100" dirty="0"/>
-          </a:p>
-        </p:txBody>
-      </p:sp>
-      <p:sp>
-        <p:nvSpPr>
-          <p:cNvPr id="14" name="Shape 11"/>
+              <a:t>Стратегия и масштабирование, система долговременного ухода, работа с государством, новые направления</a:t>
+            </a:r>
+            <a:endParaRPr lang="en-US" sz="1050" dirty="0"/>
+          </a:p>
+        </p:txBody>
+      </p:sp>
+      <p:sp>
+        <p:nvSpPr>
+          <p:cNvPr id="15" name="Shape 12"/>
           <p:cNvSpPr/>
           <p:nvPr/>
         </p:nvSpPr>
@@ -10069,7 +10264,7 @@
       </p:sp>
       <p:sp>
         <p:nvSpPr>
-          <p:cNvPr id="15" name="Shape 12"/>
+          <p:cNvPr id="16" name="Shape 13"/>
           <p:cNvSpPr/>
           <p:nvPr/>
         </p:nvSpPr>
@@ -10094,7 +10289,7 @@
       </p:sp>
       <p:pic>
         <p:nvPicPr>
-          <p:cNvPr id="16" name="Image 1" descr="img/c_team10.jpg">    </p:cNvPr>
+          <p:cNvPr id="17" name="Image 1" descr="img/c_team10.jpg">    </p:cNvPr>
           <p:cNvPicPr>
             <a:picLocks noChangeAspect="1"/>
           </p:cNvPicPr>
@@ -10118,7 +10313,7 @@
       </p:pic>
       <p:sp>
         <p:nvSpPr>
-          <p:cNvPr id="17" name="Shape 13"/>
+          <p:cNvPr id="18" name="Shape 14"/>
           <p:cNvSpPr/>
           <p:nvPr/>
         </p:nvSpPr>
@@ -10145,7 +10340,7 @@
       </p:sp>
       <p:sp>
         <p:nvSpPr>
-          <p:cNvPr id="18" name="Text 14"/>
+          <p:cNvPr id="19" name="Text 15"/>
           <p:cNvSpPr txBox="1"/>
           <p:nvPr/>
         </p:nvSpPr>
@@ -10184,7 +10379,7 @@
       </p:sp>
       <p:sp>
         <p:nvSpPr>
-          <p:cNvPr id="19" name="Text 15"/>
+          <p:cNvPr id="20" name="Text 16"/>
           <p:cNvSpPr txBox="1"/>
           <p:nvPr/>
         </p:nvSpPr>
@@ -10223,14 +10418,14 @@
       </p:sp>
       <p:sp>
         <p:nvSpPr>
-          <p:cNvPr id="20" name="Text 16"/>
-          <p:cNvSpPr txBox="1"/>
-          <p:nvPr/>
-        </p:nvSpPr>
-        <p:spPr>
-          <a:xfrm>
-            <a:off x="4507992" y="3081528"/>
-            <a:ext cx="3127248" cy="457200"/>
+          <p:cNvPr id="21" name="Text 17"/>
+          <p:cNvSpPr txBox="1"/>
+          <p:nvPr/>
+        </p:nvSpPr>
+        <p:spPr>
+          <a:xfrm>
+            <a:off x="4507992" y="3035808"/>
+            <a:ext cx="3172968" cy="548640"/>
           </a:xfrm>
           <a:prstGeom prst="rect">
             <a:avLst/>
@@ -10246,7 +10441,7 @@
               <a:buNone/>
             </a:pPr>
             <a:r>
-              <a:rPr lang="en-US" sz="1100" dirty="0">
+              <a:rPr lang="en-US" sz="1050" dirty="0">
                 <a:solidFill>
                   <a:srgbClr val="5F6B70"/>
                 </a:solidFill>
@@ -10254,15 +10449,15 @@
                 <a:ea typeface="Arial" pitchFamily="34" charset="-122"/>
                 <a:cs typeface="Arial" pitchFamily="34" charset="-120"/>
               </a:rPr>
-              <a:t>Финансовое управление, отчётность, устойчивость модели</a:t>
-            </a:r>
-            <a:endParaRPr lang="en-US" sz="1100" dirty="0"/>
-          </a:p>
-        </p:txBody>
-      </p:sp>
-      <p:sp>
-        <p:nvSpPr>
-          <p:cNvPr id="21" name="Shape 17"/>
+              <a:t>Финансы и бюджет, управленческий учёт, сопровождение госсубсидий, экономическая устойчивость</a:t>
+            </a:r>
+            <a:endParaRPr lang="en-US" sz="1050" dirty="0"/>
+          </a:p>
+        </p:txBody>
+      </p:sp>
+      <p:sp>
+        <p:nvSpPr>
+          <p:cNvPr id="22" name="Shape 18"/>
           <p:cNvSpPr/>
           <p:nvPr/>
         </p:nvSpPr>
@@ -10296,7 +10491,7 @@
       </p:sp>
       <p:sp>
         <p:nvSpPr>
-          <p:cNvPr id="22" name="Shape 18"/>
+          <p:cNvPr id="23" name="Shape 19"/>
           <p:cNvSpPr/>
           <p:nvPr/>
         </p:nvSpPr>
@@ -10321,7 +10516,7 @@
       </p:sp>
       <p:pic>
         <p:nvPicPr>
-          <p:cNvPr id="23" name="Image 2" descr="img/c_team15.jpg">    </p:cNvPr>
+          <p:cNvPr id="24" name="Image 2" descr="img/c_team15.jpg">    </p:cNvPr>
           <p:cNvPicPr>
             <a:picLocks noChangeAspect="1"/>
           </p:cNvPicPr>
@@ -10345,7 +10540,7 @@
       </p:pic>
       <p:sp>
         <p:nvSpPr>
-          <p:cNvPr id="24" name="Shape 19"/>
+          <p:cNvPr id="25" name="Shape 20"/>
           <p:cNvSpPr/>
           <p:nvPr/>
         </p:nvSpPr>
@@ -10372,7 +10567,7 @@
       </p:sp>
       <p:sp>
         <p:nvSpPr>
-          <p:cNvPr id="25" name="Text 20"/>
+          <p:cNvPr id="26" name="Text 21"/>
           <p:cNvSpPr txBox="1"/>
           <p:nvPr/>
         </p:nvSpPr>
@@ -10411,7 +10606,7 @@
       </p:sp>
       <p:sp>
         <p:nvSpPr>
-          <p:cNvPr id="26" name="Text 21"/>
+          <p:cNvPr id="27" name="Text 22"/>
           <p:cNvSpPr txBox="1"/>
           <p:nvPr/>
         </p:nvSpPr>
@@ -10450,14 +10645,14 @@
       </p:sp>
       <p:sp>
         <p:nvSpPr>
-          <p:cNvPr id="27" name="Text 22"/>
-          <p:cNvSpPr txBox="1"/>
-          <p:nvPr/>
-        </p:nvSpPr>
-        <p:spPr>
-          <a:xfrm>
-            <a:off x="8238744" y="3081528"/>
-            <a:ext cx="3127248" cy="457200"/>
+          <p:cNvPr id="28" name="Text 23"/>
+          <p:cNvSpPr txBox="1"/>
+          <p:nvPr/>
+        </p:nvSpPr>
+        <p:spPr>
+          <a:xfrm>
+            <a:off x="8238744" y="3035808"/>
+            <a:ext cx="3172968" cy="548640"/>
           </a:xfrm>
           <a:prstGeom prst="rect">
             <a:avLst/>
@@ -10473,7 +10668,7 @@
               <a:buNone/>
             </a:pPr>
             <a:r>
-              <a:rPr lang="en-US" sz="1100" dirty="0">
+              <a:rPr lang="en-US" sz="1050" dirty="0">
                 <a:solidFill>
                   <a:srgbClr val="5F6B70"/>
                 </a:solidFill>
@@ -10481,15 +10676,15 @@
                 <a:ea typeface="Arial" pitchFamily="34" charset="-122"/>
                 <a:cs typeface="Arial" pitchFamily="34" charset="-120"/>
               </a:rPr>
-              <a:t>Текущие бизнес-процессы, координация подразделений</a:t>
-            </a:r>
-            <a:endParaRPr lang="en-US" sz="1100" dirty="0"/>
-          </a:p>
-        </p:txBody>
-      </p:sp>
-      <p:sp>
-        <p:nvSpPr>
-          <p:cNvPr id="28" name="Shape 23"/>
+              <a:t>Бизнес-процессы, координация подразделений, контроль задач, стабильная работа команды</a:t>
+            </a:r>
+            <a:endParaRPr lang="en-US" sz="1050" dirty="0"/>
+          </a:p>
+        </p:txBody>
+      </p:sp>
+      <p:sp>
+        <p:nvSpPr>
+          <p:cNvPr id="29" name="Shape 24"/>
           <p:cNvSpPr/>
           <p:nvPr/>
         </p:nvSpPr>
@@ -10523,7 +10718,7 @@
       </p:sp>
       <p:sp>
         <p:nvSpPr>
-          <p:cNvPr id="29" name="Shape 24"/>
+          <p:cNvPr id="30" name="Shape 25"/>
           <p:cNvSpPr/>
           <p:nvPr/>
         </p:nvSpPr>
@@ -10548,7 +10743,7 @@
       </p:sp>
       <p:pic>
         <p:nvPicPr>
-          <p:cNvPr id="30" name="Image 3" descr="img/c_team20.jpg">    </p:cNvPr>
+          <p:cNvPr id="31" name="Image 3" descr="img/c_team20.jpg">    </p:cNvPr>
           <p:cNvPicPr>
             <a:picLocks noChangeAspect="1"/>
           </p:cNvPicPr>
@@ -10572,7 +10767,7 @@
       </p:pic>
       <p:sp>
         <p:nvSpPr>
-          <p:cNvPr id="31" name="Shape 25"/>
+          <p:cNvPr id="32" name="Shape 26"/>
           <p:cNvSpPr/>
           <p:nvPr/>
         </p:nvSpPr>
@@ -10599,7 +10794,7 @@
       </p:sp>
       <p:sp>
         <p:nvSpPr>
-          <p:cNvPr id="32" name="Text 26"/>
+          <p:cNvPr id="33" name="Text 27"/>
           <p:cNvSpPr txBox="1"/>
           <p:nvPr/>
         </p:nvSpPr>
@@ -10638,7 +10833,7 @@
       </p:sp>
       <p:sp>
         <p:nvSpPr>
-          <p:cNvPr id="33" name="Text 27"/>
+          <p:cNvPr id="34" name="Text 28"/>
           <p:cNvSpPr txBox="1"/>
           <p:nvPr/>
         </p:nvSpPr>
@@ -10677,14 +10872,14 @@
       </p:sp>
       <p:sp>
         <p:nvSpPr>
-          <p:cNvPr id="34" name="Text 28"/>
-          <p:cNvSpPr txBox="1"/>
-          <p:nvPr/>
-        </p:nvSpPr>
-        <p:spPr>
-          <a:xfrm>
-            <a:off x="777240" y="5285232"/>
-            <a:ext cx="3127248" cy="457200"/>
+          <p:cNvPr id="35" name="Text 29"/>
+          <p:cNvSpPr txBox="1"/>
+          <p:nvPr/>
+        </p:nvSpPr>
+        <p:spPr>
+          <a:xfrm>
+            <a:off x="777240" y="5239512"/>
+            <a:ext cx="3172968" cy="548640"/>
           </a:xfrm>
           <a:prstGeom prst="rect">
             <a:avLst/>
@@ -10700,7 +10895,7 @@
               <a:buNone/>
             </a:pPr>
             <a:r>
-              <a:rPr lang="en-US" sz="1100" dirty="0">
+              <a:rPr lang="en-US" sz="1050" dirty="0">
                 <a:solidFill>
                   <a:srgbClr val="5F6B70"/>
                 </a:solidFill>
@@ -10708,15 +10903,15 @@
                 <a:ea typeface="Arial" pitchFamily="34" charset="-122"/>
                 <a:cs typeface="Arial" pitchFamily="34" charset="-120"/>
               </a:rPr>
-              <a:t>Пансионаты: качество ухода и стандарты персонала</a:t>
-            </a:r>
-            <a:endParaRPr lang="en-US" sz="1100" dirty="0"/>
-          </a:p>
-        </p:txBody>
-      </p:sp>
-      <p:sp>
-        <p:nvSpPr>
-          <p:cNvPr id="35" name="Shape 29"/>
+              <a:t>Управление пансионатами, стационарный уход, персонал, контроль качества и стандартов</a:t>
+            </a:r>
+            <a:endParaRPr lang="en-US" sz="1050" dirty="0"/>
+          </a:p>
+        </p:txBody>
+      </p:sp>
+      <p:sp>
+        <p:nvSpPr>
+          <p:cNvPr id="36" name="Shape 30"/>
           <p:cNvSpPr/>
           <p:nvPr/>
         </p:nvSpPr>
@@ -10750,7 +10945,7 @@
       </p:sp>
       <p:sp>
         <p:nvSpPr>
-          <p:cNvPr id="36" name="Shape 30"/>
+          <p:cNvPr id="37" name="Shape 31"/>
           <p:cNvSpPr/>
           <p:nvPr/>
         </p:nvSpPr>
@@ -10775,7 +10970,7 @@
       </p:sp>
       <p:pic>
         <p:nvPicPr>
-          <p:cNvPr id="37" name="Image 4" descr="img/c_team25.jpg">    </p:cNvPr>
+          <p:cNvPr id="38" name="Image 4" descr="img/c_team25.jpg">    </p:cNvPr>
           <p:cNvPicPr>
             <a:picLocks noChangeAspect="1"/>
           </p:cNvPicPr>
@@ -10799,7 +10994,7 @@
       </p:pic>
       <p:sp>
         <p:nvSpPr>
-          <p:cNvPr id="38" name="Shape 31"/>
+          <p:cNvPr id="39" name="Shape 32"/>
           <p:cNvSpPr/>
           <p:nvPr/>
         </p:nvSpPr>
@@ -10826,7 +11021,7 @@
       </p:sp>
       <p:sp>
         <p:nvSpPr>
-          <p:cNvPr id="39" name="Text 32"/>
+          <p:cNvPr id="40" name="Text 33"/>
           <p:cNvSpPr txBox="1"/>
           <p:nvPr/>
         </p:nvSpPr>
@@ -10865,7 +11060,7 @@
       </p:sp>
       <p:sp>
         <p:nvSpPr>
-          <p:cNvPr id="40" name="Text 33"/>
+          <p:cNvPr id="41" name="Text 34"/>
           <p:cNvSpPr txBox="1"/>
           <p:nvPr/>
         </p:nvSpPr>
@@ -10904,14 +11099,14 @@
       </p:sp>
       <p:sp>
         <p:nvSpPr>
-          <p:cNvPr id="41" name="Text 34"/>
-          <p:cNvSpPr txBox="1"/>
-          <p:nvPr/>
-        </p:nvSpPr>
-        <p:spPr>
-          <a:xfrm>
-            <a:off x="4507992" y="5285232"/>
-            <a:ext cx="3127248" cy="457200"/>
+          <p:cNvPr id="42" name="Text 35"/>
+          <p:cNvSpPr txBox="1"/>
+          <p:nvPr/>
+        </p:nvSpPr>
+        <p:spPr>
+          <a:xfrm>
+            <a:off x="4507992" y="5239512"/>
+            <a:ext cx="3172968" cy="548640"/>
           </a:xfrm>
           <a:prstGeom prst="rect">
             <a:avLst/>
@@ -10927,7 +11122,7 @@
               <a:buNone/>
             </a:pPr>
             <a:r>
-              <a:rPr lang="en-US" sz="1100" dirty="0">
+              <a:rPr lang="en-US" sz="1050" dirty="0">
                 <a:solidFill>
                   <a:srgbClr val="5F6B70"/>
                 </a:solidFill>
@@ -10935,15 +11130,15 @@
                 <a:ea typeface="Arial" pitchFamily="34" charset="-122"/>
                 <a:cs typeface="Arial" pitchFamily="34" charset="-120"/>
               </a:rPr>
-              <a:t>Развитие и тестирование платформы Sidelka Online</a:t>
-            </a:r>
-            <a:endParaRPr lang="en-US" sz="1100" dirty="0"/>
-          </a:p>
-        </p:txBody>
-      </p:sp>
-      <p:sp>
-        <p:nvSpPr>
-          <p:cNvPr id="42" name="Shape 35"/>
+              <a:t>IT-продукты, разработка и продуктовая аналитика, Sidelka Online, цифровизация ухода</a:t>
+            </a:r>
+            <a:endParaRPr lang="en-US" sz="1050" dirty="0"/>
+          </a:p>
+        </p:txBody>
+      </p:sp>
+      <p:sp>
+        <p:nvSpPr>
+          <p:cNvPr id="43" name="Shape 36"/>
           <p:cNvSpPr/>
           <p:nvPr/>
         </p:nvSpPr>
@@ -10977,7 +11172,7 @@
       </p:sp>
       <p:sp>
         <p:nvSpPr>
-          <p:cNvPr id="43" name="Shape 36"/>
+          <p:cNvPr id="44" name="Shape 37"/>
           <p:cNvSpPr/>
           <p:nvPr/>
         </p:nvSpPr>
@@ -11002,7 +11197,7 @@
       </p:sp>
       <p:pic>
         <p:nvPicPr>
-          <p:cNvPr id="44" name="Image 5" descr="img/c_team30.jpg">    </p:cNvPr>
+          <p:cNvPr id="45" name="Image 5" descr="img/c_team30.jpg">    </p:cNvPr>
           <p:cNvPicPr>
             <a:picLocks noChangeAspect="1"/>
           </p:cNvPicPr>
@@ -11026,7 +11221,7 @@
       </p:pic>
       <p:sp>
         <p:nvSpPr>
-          <p:cNvPr id="45" name="Shape 37"/>
+          <p:cNvPr id="46" name="Shape 38"/>
           <p:cNvSpPr/>
           <p:nvPr/>
         </p:nvSpPr>
@@ -11053,7 +11248,7 @@
       </p:sp>
       <p:sp>
         <p:nvSpPr>
-          <p:cNvPr id="46" name="Text 38"/>
+          <p:cNvPr id="47" name="Text 39"/>
           <p:cNvSpPr txBox="1"/>
           <p:nvPr/>
         </p:nvSpPr>
@@ -11092,7 +11287,7 @@
       </p:sp>
       <p:sp>
         <p:nvSpPr>
-          <p:cNvPr id="47" name="Text 39"/>
+          <p:cNvPr id="48" name="Text 40"/>
           <p:cNvSpPr txBox="1"/>
           <p:nvPr/>
         </p:nvSpPr>
@@ -11131,14 +11326,14 @@
       </p:sp>
       <p:sp>
         <p:nvSpPr>
-          <p:cNvPr id="48" name="Text 40"/>
-          <p:cNvSpPr txBox="1"/>
-          <p:nvPr/>
-        </p:nvSpPr>
-        <p:spPr>
-          <a:xfrm>
-            <a:off x="8238744" y="5285232"/>
-            <a:ext cx="3127248" cy="457200"/>
+          <p:cNvPr id="49" name="Text 41"/>
+          <p:cNvSpPr txBox="1"/>
+          <p:nvPr/>
+        </p:nvSpPr>
+        <p:spPr>
+          <a:xfrm>
+            <a:off x="8238744" y="5239512"/>
+            <a:ext cx="3172968" cy="548640"/>
           </a:xfrm>
           <a:prstGeom prst="rect">
             <a:avLst/>
@@ -11154,7 +11349,7 @@
               <a:buNone/>
             </a:pPr>
             <a:r>
-              <a:rPr lang="en-US" sz="1100" dirty="0">
+              <a:rPr lang="en-US" sz="1050" dirty="0">
                 <a:solidFill>
                   <a:srgbClr val="5F6B70"/>
                 </a:solidFill>
@@ -11162,15 +11357,15 @@
                 <a:ea typeface="Arial" pitchFamily="34" charset="-122"/>
                 <a:cs typeface="Arial" pitchFamily="34" charset="-120"/>
               </a:rPr>
-              <a:t>Сопровождение подопечных и поддержка родственников</a:t>
-            </a:r>
-            <a:endParaRPr lang="en-US" sz="1100" dirty="0"/>
-          </a:p>
-        </p:txBody>
-      </p:sp>
-      <p:sp>
-        <p:nvSpPr>
-          <p:cNvPr id="49" name="Text 41"/>
+              <a:t>Психологическая поддержка подопечных и родственников, профилактика выгорания команды</a:t>
+            </a:r>
+            <a:endParaRPr lang="en-US" sz="1050" dirty="0"/>
+          </a:p>
+        </p:txBody>
+      </p:sp>
+      <p:sp>
+        <p:nvSpPr>
+          <p:cNvPr id="50" name="Text 42"/>
           <p:cNvSpPr txBox="1"/>
           <p:nvPr/>
         </p:nvSpPr>
@@ -11201,7 +11396,7 @@
                 <a:ea typeface="Arial" pitchFamily="34" charset="-122"/>
                 <a:cs typeface="Arial" pitchFamily="34" charset="-120"/>
               </a:rPr>
-              <a:t>1 000+ </a:t>
+              <a:t>1 000+* </a:t>
             </a:r>
             <a:pPr indent="0" marL="0">
               <a:buNone/>
@@ -11261,8 +11456,8 @@
         </p:nvSpPr>
         <p:spPr>
           <a:xfrm>
-            <a:off x="548640" y="6473952"/>
-            <a:ext cx="6400800" cy="201168"/>
+            <a:off x="548640" y="6565392"/>
+            <a:ext cx="6400800" cy="182880"/>
           </a:xfrm>
           <a:prstGeom prst="rect">
             <a:avLst/>
@@ -11300,8 +11495,8 @@
         </p:nvSpPr>
         <p:spPr>
           <a:xfrm>
-            <a:off x="10543032" y="6473952"/>
-            <a:ext cx="1097280" cy="201168"/>
+            <a:off x="10543032" y="6565392"/>
+            <a:ext cx="1097280" cy="182880"/>
           </a:xfrm>
           <a:prstGeom prst="rect">
             <a:avLst/>

</xml_diff>

<commit_message>
Pitch v8: footnote credits P. A. Petrova, finances marked as group-level
Co-Authored-By: Claude Opus 5.5 <noreply@anthropic.com>
Claude-Session: https://claude.ai/code/session_01DZfKE2Qbh1BJBTBdA16C3f
</commit_message>
<xml_diff>
--- a/grant/Sodeystvie_pitch_v8.pptx
+++ b/grant/Sodeystvie_pitch_v8.pptx
@@ -2291,8 +2291,8 @@
         </p:nvSpPr>
         <p:spPr>
           <a:xfrm>
-            <a:off x="548640" y="6510528"/>
-            <a:ext cx="6035040" cy="274320"/>
+            <a:off x="548640" y="6419088"/>
+            <a:ext cx="6035040" cy="384048"/>
           </a:xfrm>
           <a:prstGeom prst="rect">
             <a:avLst/>
@@ -2316,7 +2316,7 @@
                 <a:ea typeface="Arial" pitchFamily="34" charset="-122"/>
                 <a:cs typeface="Arial" pitchFamily="34" charset="-120"/>
               </a:rPr>
-              <a:t>* Показатели группы организаций «Содействие»: АНО ЦСО «Содействие», АНО РЦСП «Содействие», АНО ПЦСП «Содействие» — единая система долговременного ухода</a:t>
+              <a:t>* Показатели группы организаций «Содействие» (АНО ЦСО, АНО РЦСП, АНО ПЦСП «Содействие») — единая система долговременного ухода, созданная под руководством П. А. Петровой</a:t>
             </a:r>
             <a:endParaRPr lang="en-US" sz="800" dirty="0"/>
           </a:p>
@@ -4500,7 +4500,7 @@
                 <a:ea typeface="Arial" pitchFamily="34" charset="-122"/>
                 <a:cs typeface="Arial" pitchFamily="34" charset="-120"/>
               </a:rPr>
-              <a:t>* Показатели группы организаций «Содействие»: АНО ЦСО «Содействие», АНО РЦСП «Содействие», АНО ПЦСП «Содействие» — единая система долговременного ухода</a:t>
+              <a:t>* Показатели группы организаций «Содействие» (АНО ЦСО, АНО РЦСП, АНО ПЦСП «Содействие») — единая система долговременного ухода, созданная под руководством П. А. Петровой</a:t>
             </a:r>
             <a:endParaRPr lang="en-US" sz="850" dirty="0"/>
           </a:p>
@@ -6363,7 +6363,7 @@
                 <a:ea typeface="Arial" pitchFamily="34" charset="-122"/>
                 <a:cs typeface="Arial" pitchFamily="34" charset="-120"/>
               </a:rPr>
-              <a:t>* Показатели группы организаций «Содействие»: АНО ЦСО «Содействие», АНО РЦСП «Содействие», АНО ПЦСП «Содействие» — единая система долговременного ухода</a:t>
+              <a:t>* Показатели группы организаций «Содействие» (АНО ЦСО, АНО РЦСП, АНО ПЦСП «Содействие») — единая система долговременного ухода, созданная под руководством П. А. Петровой</a:t>
             </a:r>
             <a:endParaRPr lang="en-US" sz="850" dirty="0"/>
           </a:p>
@@ -7643,7 +7643,7 @@
                 <a:ea typeface="Arial" pitchFamily="34" charset="-122"/>
                 <a:cs typeface="Arial" pitchFamily="34" charset="-120"/>
               </a:rPr>
-              <a:t>Финансовые показатели</a:t>
+              <a:t>Финансовые показатели*</a:t>
             </a:r>
             <a:endParaRPr lang="en-US" sz="1200" dirty="0"/>
           </a:p>
@@ -8422,7 +8422,7 @@
                 <a:ea typeface="Arial" pitchFamily="34" charset="-122"/>
                 <a:cs typeface="Arial" pitchFamily="34" charset="-120"/>
               </a:rPr>
-              <a:t>* Показатели группы организаций «Содействие»: АНО ЦСО «Содействие», АНО РЦСП «Содействие», АНО ПЦСП «Содействие» — единая система долговременного ухода</a:t>
+              <a:t>* Показатели группы организаций «Содействие» (АНО ЦСО, АНО РЦСП, АНО ПЦСП «Содействие») — единая система долговременного ухода, созданная под руководством П. А. Петровой</a:t>
             </a:r>
             <a:endParaRPr lang="en-US" sz="850" dirty="0"/>
           </a:p>
@@ -9995,7 +9995,7 @@
                 <a:ea typeface="Arial" pitchFamily="34" charset="-122"/>
                 <a:cs typeface="Arial" pitchFamily="34" charset="-120"/>
               </a:rPr>
-              <a:t>* Показатели группы организаций «Содействие»: АНО ЦСО «Содействие», АНО РЦСП «Содействие», АНО ПЦСП «Содействие» — единая система долговременного ухода</a:t>
+              <a:t>* Показатели группы организаций «Содействие» (АНО ЦСО, АНО РЦСП, АНО ПЦСП «Содействие») — единая система долговременного ухода, созданная под руководством П. А. Петровой</a:t>
             </a:r>
             <a:endParaRPr lang="en-US" sz="850" dirty="0"/>
           </a:p>

</xml_diff>

<commit_message>
Pitch v8: add group financials (revenue 2025/2026, B2C growth, average check, revenue mix)
Co-Authored-By: Claude Opus 5.5 <noreply@anthropic.com>
Claude-Session: https://claude.ai/code/session_01DZfKE2Qbh1BJBTBdA16C3f
</commit_message>
<xml_diff>
--- a/grant/Sodeystvie_pitch_v8.pptx
+++ b/grant/Sodeystvie_pitch_v8.pptx
@@ -7618,8 +7618,8 @@
         </p:nvSpPr>
         <p:spPr>
           <a:xfrm>
-            <a:off x="804672" y="5047488"/>
-            <a:ext cx="3657600" cy="274320"/>
+            <a:off x="804672" y="5029200"/>
+            <a:ext cx="4572000" cy="274320"/>
           </a:xfrm>
           <a:prstGeom prst="rect">
             <a:avLst/>
@@ -7643,7 +7643,7 @@
                 <a:ea typeface="Arial" pitchFamily="34" charset="-122"/>
                 <a:cs typeface="Arial" pitchFamily="34" charset="-120"/>
               </a:rPr>
-              <a:t>Финансовые показатели*</a:t>
+              <a:t>Финансовые показатели группы*</a:t>
             </a:r>
             <a:endParaRPr lang="en-US" sz="1200" dirty="0"/>
           </a:p>
@@ -7651,290 +7651,532 @@
       </p:sp>
       <p:sp>
         <p:nvSpPr>
-          <p:cNvPr id="47" name="Shape 36"/>
+          <p:cNvPr id="47" name="Text 36"/>
+          <p:cNvSpPr txBox="1"/>
+          <p:nvPr/>
+        </p:nvSpPr>
+        <p:spPr>
+          <a:xfrm>
+            <a:off x="804672" y="5349240"/>
+            <a:ext cx="1874520" cy="457200"/>
+          </a:xfrm>
+          <a:prstGeom prst="rect">
+            <a:avLst/>
+          </a:prstGeom>
+          <a:noFill/>
+          <a:ln/>
+        </p:spPr>
+        <p:txBody>
+          <a:bodyPr wrap="square" lIns="0" tIns="0" rIns="0" bIns="0" rtlCol="0" anchor="ctr"/>
+          <a:lstStyle/>
+          <a:p>
+            <a:pPr indent="0" marL="0">
+              <a:buNone/>
+            </a:pPr>
+            <a:r>
+              <a:rPr lang="en-US" sz="2200" b="1" dirty="0">
+                <a:solidFill>
+                  <a:srgbClr val="064C49"/>
+                </a:solidFill>
+                <a:latin typeface="Arial" pitchFamily="34" charset="0"/>
+                <a:ea typeface="Arial" pitchFamily="34" charset="-122"/>
+                <a:cs typeface="Arial" pitchFamily="34" charset="-120"/>
+              </a:rPr>
+              <a:t>309,5 млн ₽</a:t>
+            </a:r>
+            <a:endParaRPr lang="en-US" sz="2200" dirty="0"/>
+          </a:p>
+        </p:txBody>
+      </p:sp>
+      <p:sp>
+        <p:nvSpPr>
+          <p:cNvPr id="48" name="Text 37"/>
+          <p:cNvSpPr txBox="1"/>
+          <p:nvPr/>
+        </p:nvSpPr>
+        <p:spPr>
+          <a:xfrm>
+            <a:off x="804672" y="5824728"/>
+            <a:ext cx="1874520" cy="274320"/>
+          </a:xfrm>
+          <a:prstGeom prst="rect">
+            <a:avLst/>
+          </a:prstGeom>
+          <a:noFill/>
+          <a:ln/>
+        </p:spPr>
+        <p:txBody>
+          <a:bodyPr wrap="square" lIns="0" tIns="0" rIns="0" bIns="0" rtlCol="0" anchor="t"/>
+          <a:lstStyle/>
+          <a:p>
+            <a:pPr indent="0" marL="0">
+              <a:buNone/>
+            </a:pPr>
+            <a:r>
+              <a:rPr lang="en-US" sz="1050" dirty="0">
+                <a:solidFill>
+                  <a:srgbClr val="5F6B70"/>
+                </a:solidFill>
+                <a:latin typeface="Arial" pitchFamily="34" charset="0"/>
+                <a:ea typeface="Arial" pitchFamily="34" charset="-122"/>
+                <a:cs typeface="Arial" pitchFamily="34" charset="-120"/>
+              </a:rPr>
+              <a:t>выручка 2025</a:t>
+            </a:r>
+            <a:endParaRPr lang="en-US" sz="1050" dirty="0"/>
+          </a:p>
+        </p:txBody>
+      </p:sp>
+      <p:sp>
+        <p:nvSpPr>
+          <p:cNvPr id="49" name="Shape 38"/>
           <p:cNvSpPr/>
           <p:nvPr/>
         </p:nvSpPr>
         <p:spPr>
           <a:xfrm>
-            <a:off x="804672" y="5376672"/>
-            <a:ext cx="1933042" cy="457200"/>
-          </a:xfrm>
-          <a:prstGeom prst="roundRect">
-            <a:avLst>
-              <a:gd name="adj" fmla="val 16000"/>
-            </a:avLst>
+            <a:off x="2679192" y="5413248"/>
+            <a:ext cx="0" cy="685800"/>
+          </a:xfrm>
+          <a:prstGeom prst="line">
+            <a:avLst/>
+          </a:prstGeom>
+          <a:noFill/>
+          <a:ln w="12700">
+            <a:solidFill>
+              <a:srgbClr val="EEE6DA"/>
+            </a:solidFill>
+            <a:prstDash val="solid"/>
+          </a:ln>
+        </p:spPr>
+      </p:sp>
+      <p:sp>
+        <p:nvSpPr>
+          <p:cNvPr id="50" name="Text 39"/>
+          <p:cNvSpPr txBox="1"/>
+          <p:nvPr/>
+        </p:nvSpPr>
+        <p:spPr>
+          <a:xfrm>
+            <a:off x="2816352" y="5349240"/>
+            <a:ext cx="1874520" cy="457200"/>
+          </a:xfrm>
+          <a:prstGeom prst="rect">
+            <a:avLst/>
+          </a:prstGeom>
+          <a:noFill/>
+          <a:ln/>
+        </p:spPr>
+        <p:txBody>
+          <a:bodyPr wrap="square" lIns="0" tIns="0" rIns="0" bIns="0" rtlCol="0" anchor="ctr"/>
+          <a:lstStyle/>
+          <a:p>
+            <a:pPr indent="0" marL="0">
+              <a:buNone/>
+            </a:pPr>
+            <a:r>
+              <a:rPr lang="en-US" sz="2200" b="1" dirty="0">
+                <a:solidFill>
+                  <a:srgbClr val="D9824F"/>
+                </a:solidFill>
+                <a:latin typeface="Arial" pitchFamily="34" charset="0"/>
+                <a:ea typeface="Arial" pitchFamily="34" charset="-122"/>
+                <a:cs typeface="Arial" pitchFamily="34" charset="-120"/>
+              </a:rPr>
+              <a:t>403,3 млн ₽</a:t>
+            </a:r>
+            <a:endParaRPr lang="en-US" sz="2200" dirty="0"/>
+          </a:p>
+        </p:txBody>
+      </p:sp>
+      <p:sp>
+        <p:nvSpPr>
+          <p:cNvPr id="51" name="Text 40"/>
+          <p:cNvSpPr txBox="1"/>
+          <p:nvPr/>
+        </p:nvSpPr>
+        <p:spPr>
+          <a:xfrm>
+            <a:off x="2816352" y="5824728"/>
+            <a:ext cx="1874520" cy="274320"/>
+          </a:xfrm>
+          <a:prstGeom prst="rect">
+            <a:avLst/>
+          </a:prstGeom>
+          <a:noFill/>
+          <a:ln/>
+        </p:spPr>
+        <p:txBody>
+          <a:bodyPr wrap="square" lIns="0" tIns="0" rIns="0" bIns="0" rtlCol="0" anchor="t"/>
+          <a:lstStyle/>
+          <a:p>
+            <a:pPr indent="0" marL="0">
+              <a:buNone/>
+            </a:pPr>
+            <a:r>
+              <a:rPr lang="en-US" sz="1050" dirty="0">
+                <a:solidFill>
+                  <a:srgbClr val="5F6B70"/>
+                </a:solidFill>
+                <a:latin typeface="Arial" pitchFamily="34" charset="0"/>
+                <a:ea typeface="Arial" pitchFamily="34" charset="-122"/>
+                <a:cs typeface="Arial" pitchFamily="34" charset="-120"/>
+              </a:rPr>
+              <a:t>прогноз 2026, +30% к 2025</a:t>
+            </a:r>
+            <a:endParaRPr lang="en-US" sz="1050" dirty="0"/>
+          </a:p>
+        </p:txBody>
+      </p:sp>
+      <p:sp>
+        <p:nvSpPr>
+          <p:cNvPr id="52" name="Shape 41"/>
+          <p:cNvSpPr/>
+          <p:nvPr/>
+        </p:nvSpPr>
+        <p:spPr>
+          <a:xfrm>
+            <a:off x="4690872" y="5413248"/>
+            <a:ext cx="0" cy="685800"/>
+          </a:xfrm>
+          <a:prstGeom prst="line">
+            <a:avLst/>
+          </a:prstGeom>
+          <a:noFill/>
+          <a:ln w="12700">
+            <a:solidFill>
+              <a:srgbClr val="EEE6DA"/>
+            </a:solidFill>
+            <a:prstDash val="solid"/>
+          </a:ln>
+        </p:spPr>
+      </p:sp>
+      <p:sp>
+        <p:nvSpPr>
+          <p:cNvPr id="53" name="Text 42"/>
+          <p:cNvSpPr txBox="1"/>
+          <p:nvPr/>
+        </p:nvSpPr>
+        <p:spPr>
+          <a:xfrm>
+            <a:off x="4828032" y="5349240"/>
+            <a:ext cx="1874520" cy="457200"/>
+          </a:xfrm>
+          <a:prstGeom prst="rect">
+            <a:avLst/>
+          </a:prstGeom>
+          <a:noFill/>
+          <a:ln/>
+        </p:spPr>
+        <p:txBody>
+          <a:bodyPr wrap="square" lIns="0" tIns="0" rIns="0" bIns="0" rtlCol="0" anchor="ctr"/>
+          <a:lstStyle/>
+          <a:p>
+            <a:pPr indent="0" marL="0">
+              <a:buNone/>
+            </a:pPr>
+            <a:r>
+              <a:rPr lang="en-US" sz="2200" b="1" dirty="0">
+                <a:solidFill>
+                  <a:srgbClr val="064C49"/>
+                </a:solidFill>
+                <a:latin typeface="Arial" pitchFamily="34" charset="0"/>
+                <a:ea typeface="Arial" pitchFamily="34" charset="-122"/>
+                <a:cs typeface="Arial" pitchFamily="34" charset="-120"/>
+              </a:rPr>
+              <a:t>+57%</a:t>
+            </a:r>
+            <a:endParaRPr lang="en-US" sz="2200" dirty="0"/>
+          </a:p>
+        </p:txBody>
+      </p:sp>
+      <p:sp>
+        <p:nvSpPr>
+          <p:cNvPr id="54" name="Text 43"/>
+          <p:cNvSpPr txBox="1"/>
+          <p:nvPr/>
+        </p:nvSpPr>
+        <p:spPr>
+          <a:xfrm>
+            <a:off x="4828032" y="5824728"/>
+            <a:ext cx="1874520" cy="274320"/>
+          </a:xfrm>
+          <a:prstGeom prst="rect">
+            <a:avLst/>
+          </a:prstGeom>
+          <a:noFill/>
+          <a:ln/>
+        </p:spPr>
+        <p:txBody>
+          <a:bodyPr wrap="square" lIns="0" tIns="0" rIns="0" bIns="0" rtlCol="0" anchor="t"/>
+          <a:lstStyle/>
+          <a:p>
+            <a:pPr indent="0" marL="0">
+              <a:buNone/>
+            </a:pPr>
+            <a:r>
+              <a:rPr lang="en-US" sz="1050" dirty="0">
+                <a:solidFill>
+                  <a:srgbClr val="5F6B70"/>
+                </a:solidFill>
+                <a:latin typeface="Arial" pitchFamily="34" charset="0"/>
+                <a:ea typeface="Arial" pitchFamily="34" charset="-122"/>
+                <a:cs typeface="Arial" pitchFamily="34" charset="-120"/>
+              </a:rPr>
+              <a:t>рост выручки B2C за год</a:t>
+            </a:r>
+            <a:endParaRPr lang="en-US" sz="1050" dirty="0"/>
+          </a:p>
+        </p:txBody>
+      </p:sp>
+      <p:sp>
+        <p:nvSpPr>
+          <p:cNvPr id="55" name="Shape 44"/>
+          <p:cNvSpPr/>
+          <p:nvPr/>
+        </p:nvSpPr>
+        <p:spPr>
+          <a:xfrm>
+            <a:off x="6702552" y="5413248"/>
+            <a:ext cx="0" cy="685800"/>
+          </a:xfrm>
+          <a:prstGeom prst="line">
+            <a:avLst/>
+          </a:prstGeom>
+          <a:noFill/>
+          <a:ln w="12700">
+            <a:solidFill>
+              <a:srgbClr val="EEE6DA"/>
+            </a:solidFill>
+            <a:prstDash val="solid"/>
+          </a:ln>
+        </p:spPr>
+      </p:sp>
+      <p:sp>
+        <p:nvSpPr>
+          <p:cNvPr id="56" name="Text 45"/>
+          <p:cNvSpPr txBox="1"/>
+          <p:nvPr/>
+        </p:nvSpPr>
+        <p:spPr>
+          <a:xfrm>
+            <a:off x="6839712" y="5349240"/>
+            <a:ext cx="1874520" cy="457200"/>
+          </a:xfrm>
+          <a:prstGeom prst="rect">
+            <a:avLst/>
+          </a:prstGeom>
+          <a:noFill/>
+          <a:ln/>
+        </p:spPr>
+        <p:txBody>
+          <a:bodyPr wrap="square" lIns="0" tIns="0" rIns="0" bIns="0" rtlCol="0" anchor="ctr"/>
+          <a:lstStyle/>
+          <a:p>
+            <a:pPr indent="0" marL="0">
+              <a:buNone/>
+            </a:pPr>
+            <a:r>
+              <a:rPr lang="en-US" sz="2200" b="1" dirty="0">
+                <a:solidFill>
+                  <a:srgbClr val="064C49"/>
+                </a:solidFill>
+                <a:latin typeface="Arial" pitchFamily="34" charset="0"/>
+                <a:ea typeface="Arial" pitchFamily="34" charset="-122"/>
+                <a:cs typeface="Arial" pitchFamily="34" charset="-120"/>
+              </a:rPr>
+              <a:t>2 600 ₽</a:t>
+            </a:r>
+            <a:endParaRPr lang="en-US" sz="2200" dirty="0"/>
+          </a:p>
+        </p:txBody>
+      </p:sp>
+      <p:sp>
+        <p:nvSpPr>
+          <p:cNvPr id="57" name="Text 46"/>
+          <p:cNvSpPr txBox="1"/>
+          <p:nvPr/>
+        </p:nvSpPr>
+        <p:spPr>
+          <a:xfrm>
+            <a:off x="6839712" y="5824728"/>
+            <a:ext cx="1874520" cy="274320"/>
+          </a:xfrm>
+          <a:prstGeom prst="rect">
+            <a:avLst/>
+          </a:prstGeom>
+          <a:noFill/>
+          <a:ln/>
+        </p:spPr>
+        <p:txBody>
+          <a:bodyPr wrap="square" lIns="0" tIns="0" rIns="0" bIns="0" rtlCol="0" anchor="t"/>
+          <a:lstStyle/>
+          <a:p>
+            <a:pPr indent="0" marL="0">
+              <a:buNone/>
+            </a:pPr>
+            <a:r>
+              <a:rPr lang="en-US" sz="1050" dirty="0">
+                <a:solidFill>
+                  <a:srgbClr val="5F6B70"/>
+                </a:solidFill>
+                <a:latin typeface="Arial" pitchFamily="34" charset="0"/>
+                <a:ea typeface="Arial" pitchFamily="34" charset="-122"/>
+                <a:cs typeface="Arial" pitchFamily="34" charset="-120"/>
+              </a:rPr>
+              <a:t>средний чек, пансионат</a:t>
+            </a:r>
+            <a:endParaRPr lang="en-US" sz="1050" dirty="0"/>
+          </a:p>
+        </p:txBody>
+      </p:sp>
+      <p:sp>
+        <p:nvSpPr>
+          <p:cNvPr id="58" name="Shape 47"/>
+          <p:cNvSpPr/>
+          <p:nvPr/>
+        </p:nvSpPr>
+        <p:spPr>
+          <a:xfrm>
+            <a:off x="8686800" y="5413248"/>
+            <a:ext cx="0" cy="685800"/>
+          </a:xfrm>
+          <a:prstGeom prst="line">
+            <a:avLst/>
+          </a:prstGeom>
+          <a:noFill/>
+          <a:ln w="12700">
+            <a:solidFill>
+              <a:srgbClr val="EEE6DA"/>
+            </a:solidFill>
+            <a:prstDash val="solid"/>
+          </a:ln>
+        </p:spPr>
+      </p:sp>
+      <p:sp>
+        <p:nvSpPr>
+          <p:cNvPr id="59" name="Text 48"/>
+          <p:cNvSpPr txBox="1"/>
+          <p:nvPr/>
+        </p:nvSpPr>
+        <p:spPr>
+          <a:xfrm>
+            <a:off x="8823960" y="5358384"/>
+            <a:ext cx="2542032" cy="228600"/>
+          </a:xfrm>
+          <a:prstGeom prst="rect">
+            <a:avLst/>
+          </a:prstGeom>
+          <a:noFill/>
+          <a:ln/>
+        </p:spPr>
+        <p:txBody>
+          <a:bodyPr wrap="square" lIns="0" tIns="0" rIns="0" bIns="0" rtlCol="0" anchor="t"/>
+          <a:lstStyle/>
+          <a:p>
+            <a:pPr indent="0" marL="0">
+              <a:buNone/>
+            </a:pPr>
+            <a:r>
+              <a:rPr lang="en-US" sz="1050" b="1" dirty="0">
+                <a:solidFill>
+                  <a:srgbClr val="1E2F33"/>
+                </a:solidFill>
+                <a:latin typeface="Arial" pitchFamily="34" charset="0"/>
+                <a:ea typeface="Arial" pitchFamily="34" charset="-122"/>
+                <a:cs typeface="Arial" pitchFamily="34" charset="-120"/>
+              </a:rPr>
+              <a:t>Структура выручки 2026</a:t>
+            </a:r>
+            <a:endParaRPr lang="en-US" sz="1050" dirty="0"/>
+          </a:p>
+        </p:txBody>
+      </p:sp>
+      <p:sp>
+        <p:nvSpPr>
+          <p:cNvPr id="60" name="Shape 49"/>
+          <p:cNvSpPr/>
+          <p:nvPr/>
+        </p:nvSpPr>
+        <p:spPr>
+          <a:xfrm>
+            <a:off x="8823960" y="5632704"/>
+            <a:ext cx="2127681" cy="182880"/>
+          </a:xfrm>
+          <a:prstGeom prst="rect">
+            <a:avLst/>
           </a:prstGeom>
           <a:solidFill>
-            <a:srgbClr val="FBF8F2"/>
+            <a:srgbClr val="0E6B65"/>
           </a:solidFill>
           <a:ln w="12700">
             <a:solidFill>
-              <a:srgbClr val="D8CDBB"/>
+              <a:srgbClr val="0E6B65"/>
             </a:solidFill>
-            <a:prstDash val="dash"/>
+            <a:prstDash val="solid"/>
           </a:ln>
         </p:spPr>
       </p:sp>
       <p:sp>
         <p:nvSpPr>
-          <p:cNvPr id="48" name="Text 37"/>
-          <p:cNvSpPr txBox="1"/>
-          <p:nvPr/>
-        </p:nvSpPr>
-        <p:spPr>
-          <a:xfrm>
-            <a:off x="804672" y="5376672"/>
-            <a:ext cx="1933042" cy="457200"/>
-          </a:xfrm>
-          <a:prstGeom prst="rect">
-            <a:avLst/>
-          </a:prstGeom>
-          <a:noFill/>
-          <a:ln/>
-        </p:spPr>
-        <p:txBody>
-          <a:bodyPr wrap="square" lIns="0" tIns="0" rIns="0" bIns="0" rtlCol="0" anchor="ctr"/>
-          <a:lstStyle/>
-          <a:p>
-            <a:pPr algn="ctr" indent="0" marL="0">
-              <a:buNone/>
-            </a:pPr>
-            <a:r>
-              <a:rPr lang="en-US" sz="1400" dirty="0">
-                <a:solidFill>
-                  <a:srgbClr val="B9AE9C"/>
-                </a:solidFill>
-                <a:latin typeface="Arial" pitchFamily="34" charset="0"/>
-                <a:ea typeface="Arial" pitchFamily="34" charset="-122"/>
-                <a:cs typeface="Arial" pitchFamily="34" charset="-120"/>
-              </a:rPr>
-              <a:t>вписать</a:t>
-            </a:r>
-            <a:endParaRPr lang="en-US" sz="1400" dirty="0"/>
-          </a:p>
-        </p:txBody>
-      </p:sp>
-      <p:sp>
-        <p:nvSpPr>
-          <p:cNvPr id="49" name="Text 38"/>
-          <p:cNvSpPr txBox="1"/>
-          <p:nvPr/>
-        </p:nvSpPr>
-        <p:spPr>
-          <a:xfrm>
-            <a:off x="804672" y="5888736"/>
-            <a:ext cx="1933042" cy="274320"/>
-          </a:xfrm>
-          <a:prstGeom prst="rect">
-            <a:avLst/>
-          </a:prstGeom>
-          <a:noFill/>
-          <a:ln/>
-        </p:spPr>
-        <p:txBody>
-          <a:bodyPr wrap="square" lIns="0" tIns="0" rIns="0" bIns="0" rtlCol="0" anchor="t"/>
-          <a:lstStyle/>
-          <a:p>
-            <a:pPr algn="ctr" indent="0" marL="0">
-              <a:buNone/>
-            </a:pPr>
-            <a:r>
-              <a:rPr lang="en-US" sz="1100" dirty="0">
-                <a:solidFill>
-                  <a:srgbClr val="5F6B70"/>
-                </a:solidFill>
-                <a:latin typeface="Arial" pitchFamily="34" charset="0"/>
-                <a:ea typeface="Arial" pitchFamily="34" charset="-122"/>
-                <a:cs typeface="Arial" pitchFamily="34" charset="-120"/>
-              </a:rPr>
-              <a:t>Выручка 2025</a:t>
-            </a:r>
-            <a:endParaRPr lang="en-US" sz="1100" dirty="0"/>
-          </a:p>
-        </p:txBody>
-      </p:sp>
-      <p:sp>
-        <p:nvSpPr>
-          <p:cNvPr id="50" name="Shape 39"/>
+          <p:cNvPr id="61" name="Shape 50"/>
           <p:cNvSpPr/>
           <p:nvPr/>
         </p:nvSpPr>
         <p:spPr>
           <a:xfrm>
-            <a:off x="2920594" y="5376672"/>
-            <a:ext cx="1933042" cy="457200"/>
-          </a:xfrm>
-          <a:prstGeom prst="roundRect">
-            <a:avLst>
-              <a:gd name="adj" fmla="val 16000"/>
-            </a:avLst>
+            <a:off x="10951641" y="5632704"/>
+            <a:ext cx="409267" cy="182880"/>
+          </a:xfrm>
+          <a:prstGeom prst="rect">
+            <a:avLst/>
           </a:prstGeom>
           <a:solidFill>
-            <a:srgbClr val="FBF8F2"/>
+            <a:srgbClr val="D9824F"/>
           </a:solidFill>
           <a:ln w="12700">
             <a:solidFill>
-              <a:srgbClr val="D8CDBB"/>
+              <a:srgbClr val="D9824F"/>
             </a:solidFill>
-            <a:prstDash val="dash"/>
+            <a:prstDash val="solid"/>
           </a:ln>
         </p:spPr>
       </p:sp>
       <p:sp>
         <p:nvSpPr>
-          <p:cNvPr id="51" name="Text 40"/>
-          <p:cNvSpPr txBox="1"/>
-          <p:nvPr/>
-        </p:nvSpPr>
-        <p:spPr>
-          <a:xfrm>
-            <a:off x="2920594" y="5376672"/>
-            <a:ext cx="1933042" cy="457200"/>
-          </a:xfrm>
-          <a:prstGeom prst="rect">
-            <a:avLst/>
-          </a:prstGeom>
-          <a:noFill/>
-          <a:ln/>
-        </p:spPr>
-        <p:txBody>
-          <a:bodyPr wrap="square" lIns="0" tIns="0" rIns="0" bIns="0" rtlCol="0" anchor="ctr"/>
-          <a:lstStyle/>
-          <a:p>
-            <a:pPr algn="ctr" indent="0" marL="0">
-              <a:buNone/>
-            </a:pPr>
-            <a:r>
-              <a:rPr lang="en-US" sz="1400" dirty="0">
-                <a:solidFill>
-                  <a:srgbClr val="B9AE9C"/>
-                </a:solidFill>
-                <a:latin typeface="Arial" pitchFamily="34" charset="0"/>
-                <a:ea typeface="Arial" pitchFamily="34" charset="-122"/>
-                <a:cs typeface="Arial" pitchFamily="34" charset="-120"/>
-              </a:rPr>
-              <a:t>вписать</a:t>
-            </a:r>
-            <a:endParaRPr lang="en-US" sz="1400" dirty="0"/>
-          </a:p>
-        </p:txBody>
-      </p:sp>
-      <p:sp>
-        <p:nvSpPr>
-          <p:cNvPr id="52" name="Text 41"/>
-          <p:cNvSpPr txBox="1"/>
-          <p:nvPr/>
-        </p:nvSpPr>
-        <p:spPr>
-          <a:xfrm>
-            <a:off x="2920594" y="5888736"/>
-            <a:ext cx="1933042" cy="274320"/>
-          </a:xfrm>
-          <a:prstGeom prst="rect">
-            <a:avLst/>
-          </a:prstGeom>
-          <a:noFill/>
-          <a:ln/>
-        </p:spPr>
-        <p:txBody>
-          <a:bodyPr wrap="square" lIns="0" tIns="0" rIns="0" bIns="0" rtlCol="0" anchor="t"/>
-          <a:lstStyle/>
-          <a:p>
-            <a:pPr algn="ctr" indent="0" marL="0">
-              <a:buNone/>
-            </a:pPr>
-            <a:r>
-              <a:rPr lang="en-US" sz="1100" dirty="0">
-                <a:solidFill>
-                  <a:srgbClr val="5F6B70"/>
-                </a:solidFill>
-                <a:latin typeface="Arial" pitchFamily="34" charset="0"/>
-                <a:ea typeface="Arial" pitchFamily="34" charset="-122"/>
-                <a:cs typeface="Arial" pitchFamily="34" charset="-120"/>
-              </a:rPr>
-              <a:t>Выручка 2026 (прогноз)</a:t>
-            </a:r>
-            <a:endParaRPr lang="en-US" sz="1100" dirty="0"/>
-          </a:p>
-        </p:txBody>
-      </p:sp>
-      <p:sp>
-        <p:nvSpPr>
-          <p:cNvPr id="53" name="Shape 42"/>
+          <p:cNvPr id="62" name="Shape 51"/>
           <p:cNvSpPr/>
           <p:nvPr/>
         </p:nvSpPr>
         <p:spPr>
           <a:xfrm>
-            <a:off x="5036515" y="5376672"/>
-            <a:ext cx="1933042" cy="457200"/>
-          </a:xfrm>
-          <a:prstGeom prst="roundRect">
-            <a:avLst>
-              <a:gd name="adj" fmla="val 16000"/>
-            </a:avLst>
+            <a:off x="11360908" y="5632704"/>
+            <a:ext cx="36576" cy="182880"/>
+          </a:xfrm>
+          <a:prstGeom prst="rect">
+            <a:avLst/>
           </a:prstGeom>
           <a:solidFill>
-            <a:srgbClr val="FBF8F2"/>
+            <a:srgbClr val="F0B47C"/>
           </a:solidFill>
           <a:ln w="12700">
             <a:solidFill>
-              <a:srgbClr val="D8CDBB"/>
+              <a:srgbClr val="F0B47C"/>
             </a:solidFill>
-            <a:prstDash val="dash"/>
+            <a:prstDash val="solid"/>
           </a:ln>
         </p:spPr>
       </p:sp>
       <p:sp>
         <p:nvSpPr>
-          <p:cNvPr id="54" name="Text 43"/>
-          <p:cNvSpPr txBox="1"/>
-          <p:nvPr/>
-        </p:nvSpPr>
-        <p:spPr>
-          <a:xfrm>
-            <a:off x="5036515" y="5376672"/>
-            <a:ext cx="1933042" cy="457200"/>
-          </a:xfrm>
-          <a:prstGeom prst="rect">
-            <a:avLst/>
-          </a:prstGeom>
-          <a:noFill/>
-          <a:ln/>
-        </p:spPr>
-        <p:txBody>
-          <a:bodyPr wrap="square" lIns="0" tIns="0" rIns="0" bIns="0" rtlCol="0" anchor="ctr"/>
-          <a:lstStyle/>
-          <a:p>
-            <a:pPr algn="ctr" indent="0" marL="0">
-              <a:buNone/>
-            </a:pPr>
-            <a:r>
-              <a:rPr lang="en-US" sz="1400" dirty="0">
-                <a:solidFill>
-                  <a:srgbClr val="B9AE9C"/>
-                </a:solidFill>
-                <a:latin typeface="Arial" pitchFamily="34" charset="0"/>
-                <a:ea typeface="Arial" pitchFamily="34" charset="-122"/>
-                <a:cs typeface="Arial" pitchFamily="34" charset="-120"/>
-              </a:rPr>
-              <a:t>вписать</a:t>
-            </a:r>
-            <a:endParaRPr lang="en-US" sz="1400" dirty="0"/>
-          </a:p>
-        </p:txBody>
-      </p:sp>
-      <p:sp>
-        <p:nvSpPr>
-          <p:cNvPr id="55" name="Text 44"/>
-          <p:cNvSpPr txBox="1"/>
-          <p:nvPr/>
-        </p:nvSpPr>
-        <p:spPr>
-          <a:xfrm>
-            <a:off x="5036515" y="5888736"/>
-            <a:ext cx="1933042" cy="274320"/>
+          <p:cNvPr id="63" name="Text 52"/>
+          <p:cNvSpPr txBox="1"/>
+          <p:nvPr/>
+        </p:nvSpPr>
+        <p:spPr>
+          <a:xfrm>
+            <a:off x="8823960" y="5870448"/>
+            <a:ext cx="2542032" cy="228600"/>
           </a:xfrm>
           <a:prstGeom prst="rect">
             <a:avLst/>
@@ -7946,11 +8188,25 @@
           <a:bodyPr wrap="square" lIns="0" tIns="0" rIns="0" bIns="0" rtlCol="0" anchor="t"/>
           <a:lstStyle/>
           <a:p>
-            <a:pPr algn="ctr" indent="0" marL="0">
-              <a:buNone/>
-            </a:pPr>
-            <a:r>
-              <a:rPr lang="en-US" sz="1100" dirty="0">
+            <a:pPr indent="0" marL="0">
+              <a:buNone/>
+            </a:pPr>
+            <a:r>
+              <a:rPr lang="en-US" sz="1000" b="1" dirty="0">
+                <a:solidFill>
+                  <a:srgbClr val="0E6B65"/>
+                </a:solidFill>
+                <a:latin typeface="Arial" pitchFamily="34" charset="0"/>
+                <a:ea typeface="Arial" pitchFamily="34" charset="-122"/>
+                <a:cs typeface="Arial" pitchFamily="34" charset="-120"/>
+              </a:rPr>
+              <a:t>B2G 84%</a:t>
+            </a:r>
+            <a:pPr indent="0" marL="0">
+              <a:buNone/>
+            </a:pPr>
+            <a:r>
+              <a:rPr lang="en-US" sz="1000" dirty="0">
                 <a:solidFill>
                   <a:srgbClr val="5F6B70"/>
                 </a:solidFill>
@@ -7958,104 +8214,27 @@
                 <a:ea typeface="Arial" pitchFamily="34" charset="-122"/>
                 <a:cs typeface="Arial" pitchFamily="34" charset="-120"/>
               </a:rPr>
-              <a:t>Прибыль</a:t>
-            </a:r>
-            <a:endParaRPr lang="en-US" sz="1100" dirty="0"/>
-          </a:p>
-        </p:txBody>
-      </p:sp>
-      <p:sp>
-        <p:nvSpPr>
-          <p:cNvPr id="56" name="Shape 45"/>
-          <p:cNvSpPr/>
-          <p:nvPr/>
-        </p:nvSpPr>
-        <p:spPr>
-          <a:xfrm>
-            <a:off x="7152437" y="5376672"/>
-            <a:ext cx="1933042" cy="457200"/>
-          </a:xfrm>
-          <a:prstGeom prst="roundRect">
-            <a:avLst>
-              <a:gd name="adj" fmla="val 16000"/>
-            </a:avLst>
-          </a:prstGeom>
-          <a:solidFill>
-            <a:srgbClr val="FBF8F2"/>
-          </a:solidFill>
-          <a:ln w="12700">
-            <a:solidFill>
-              <a:srgbClr val="D8CDBB"/>
-            </a:solidFill>
-            <a:prstDash val="dash"/>
-          </a:ln>
-        </p:spPr>
-      </p:sp>
-      <p:sp>
-        <p:nvSpPr>
-          <p:cNvPr id="57" name="Text 46"/>
-          <p:cNvSpPr txBox="1"/>
-          <p:nvPr/>
-        </p:nvSpPr>
-        <p:spPr>
-          <a:xfrm>
-            <a:off x="7152437" y="5376672"/>
-            <a:ext cx="1933042" cy="457200"/>
-          </a:xfrm>
-          <a:prstGeom prst="rect">
-            <a:avLst/>
-          </a:prstGeom>
-          <a:noFill/>
-          <a:ln/>
-        </p:spPr>
-        <p:txBody>
-          <a:bodyPr wrap="square" lIns="0" tIns="0" rIns="0" bIns="0" rtlCol="0" anchor="ctr"/>
-          <a:lstStyle/>
-          <a:p>
-            <a:pPr algn="ctr" indent="0" marL="0">
-              <a:buNone/>
-            </a:pPr>
-            <a:r>
-              <a:rPr lang="en-US" sz="1400" dirty="0">
-                <a:solidFill>
-                  <a:srgbClr val="B9AE9C"/>
-                </a:solidFill>
-                <a:latin typeface="Arial" pitchFamily="34" charset="0"/>
-                <a:ea typeface="Arial" pitchFamily="34" charset="-122"/>
-                <a:cs typeface="Arial" pitchFamily="34" charset="-120"/>
-              </a:rPr>
-              <a:t>вписать</a:t>
-            </a:r>
-            <a:endParaRPr lang="en-US" sz="1400" dirty="0"/>
-          </a:p>
-        </p:txBody>
-      </p:sp>
-      <p:sp>
-        <p:nvSpPr>
-          <p:cNvPr id="58" name="Text 47"/>
-          <p:cNvSpPr txBox="1"/>
-          <p:nvPr/>
-        </p:nvSpPr>
-        <p:spPr>
-          <a:xfrm>
-            <a:off x="7152437" y="5888736"/>
-            <a:ext cx="1933042" cy="274320"/>
-          </a:xfrm>
-          <a:prstGeom prst="rect">
-            <a:avLst/>
-          </a:prstGeom>
-          <a:noFill/>
-          <a:ln/>
-        </p:spPr>
-        <p:txBody>
-          <a:bodyPr wrap="square" lIns="0" tIns="0" rIns="0" bIns="0" rtlCol="0" anchor="t"/>
-          <a:lstStyle/>
-          <a:p>
-            <a:pPr algn="ctr" indent="0" marL="0">
-              <a:buNone/>
-            </a:pPr>
-            <a:r>
-              <a:rPr lang="en-US" sz="1100" dirty="0">
+              <a:t>  ·  </a:t>
+            </a:r>
+            <a:pPr indent="0" marL="0">
+              <a:buNone/>
+            </a:pPr>
+            <a:r>
+              <a:rPr lang="en-US" sz="1000" b="1" dirty="0">
+                <a:solidFill>
+                  <a:srgbClr val="D9824F"/>
+                </a:solidFill>
+                <a:latin typeface="Arial" pitchFamily="34" charset="0"/>
+                <a:ea typeface="Arial" pitchFamily="34" charset="-122"/>
+                <a:cs typeface="Arial" pitchFamily="34" charset="-120"/>
+              </a:rPr>
+              <a:t>B2C 16%</a:t>
+            </a:r>
+            <a:pPr indent="0" marL="0">
+              <a:buNone/>
+            </a:pPr>
+            <a:r>
+              <a:rPr lang="en-US" sz="1000" dirty="0">
                 <a:solidFill>
                   <a:srgbClr val="5F6B70"/>
                 </a:solidFill>
@@ -8063,114 +8242,23 @@
                 <a:ea typeface="Arial" pitchFamily="34" charset="-122"/>
                 <a:cs typeface="Arial" pitchFamily="34" charset="-120"/>
               </a:rPr>
-              <a:t>Средний чек B2C</a:t>
-            </a:r>
-            <a:endParaRPr lang="en-US" sz="1100" dirty="0"/>
-          </a:p>
-        </p:txBody>
-      </p:sp>
-      <p:sp>
-        <p:nvSpPr>
-          <p:cNvPr id="59" name="Shape 48"/>
-          <p:cNvSpPr/>
-          <p:nvPr/>
-        </p:nvSpPr>
-        <p:spPr>
-          <a:xfrm>
-            <a:off x="9268358" y="5376672"/>
-            <a:ext cx="1933042" cy="457200"/>
-          </a:xfrm>
-          <a:prstGeom prst="roundRect">
-            <a:avLst>
-              <a:gd name="adj" fmla="val 16000"/>
-            </a:avLst>
-          </a:prstGeom>
-          <a:solidFill>
-            <a:srgbClr val="FBF8F2"/>
-          </a:solidFill>
-          <a:ln w="12700">
-            <a:solidFill>
-              <a:srgbClr val="D8CDBB"/>
-            </a:solidFill>
-            <a:prstDash val="dash"/>
-          </a:ln>
-        </p:spPr>
-      </p:sp>
-      <p:sp>
-        <p:nvSpPr>
-          <p:cNvPr id="60" name="Text 49"/>
-          <p:cNvSpPr txBox="1"/>
-          <p:nvPr/>
-        </p:nvSpPr>
-        <p:spPr>
-          <a:xfrm>
-            <a:off x="9268358" y="5376672"/>
-            <a:ext cx="1933042" cy="457200"/>
-          </a:xfrm>
-          <a:prstGeom prst="rect">
-            <a:avLst/>
-          </a:prstGeom>
-          <a:noFill/>
-          <a:ln/>
-        </p:spPr>
-        <p:txBody>
-          <a:bodyPr wrap="square" lIns="0" tIns="0" rIns="0" bIns="0" rtlCol="0" anchor="ctr"/>
-          <a:lstStyle/>
-          <a:p>
-            <a:pPr algn="ctr" indent="0" marL="0">
-              <a:buNone/>
-            </a:pPr>
-            <a:r>
-              <a:rPr lang="en-US" sz="1400" dirty="0">
-                <a:solidFill>
-                  <a:srgbClr val="B9AE9C"/>
-                </a:solidFill>
-                <a:latin typeface="Arial" pitchFamily="34" charset="0"/>
-                <a:ea typeface="Arial" pitchFamily="34" charset="-122"/>
-                <a:cs typeface="Arial" pitchFamily="34" charset="-120"/>
-              </a:rPr>
-              <a:t>вписать</a:t>
-            </a:r>
-            <a:endParaRPr lang="en-US" sz="1400" dirty="0"/>
-          </a:p>
-        </p:txBody>
-      </p:sp>
-      <p:sp>
-        <p:nvSpPr>
-          <p:cNvPr id="61" name="Text 50"/>
-          <p:cNvSpPr txBox="1"/>
-          <p:nvPr/>
-        </p:nvSpPr>
-        <p:spPr>
-          <a:xfrm>
-            <a:off x="9268358" y="5888736"/>
-            <a:ext cx="1933042" cy="274320"/>
-          </a:xfrm>
-          <a:prstGeom prst="rect">
-            <a:avLst/>
-          </a:prstGeom>
-          <a:noFill/>
-          <a:ln/>
-        </p:spPr>
-        <p:txBody>
-          <a:bodyPr wrap="square" lIns="0" tIns="0" rIns="0" bIns="0" rtlCol="0" anchor="t"/>
-          <a:lstStyle/>
-          <a:p>
-            <a:pPr algn="ctr" indent="0" marL="0">
-              <a:buNone/>
-            </a:pPr>
-            <a:r>
-              <a:rPr lang="en-US" sz="1100" dirty="0">
-                <a:solidFill>
-                  <a:srgbClr val="5F6B70"/>
-                </a:solidFill>
-                <a:latin typeface="Arial" pitchFamily="34" charset="0"/>
-                <a:ea typeface="Arial" pitchFamily="34" charset="-122"/>
-                <a:cs typeface="Arial" pitchFamily="34" charset="-120"/>
-              </a:rPr>
-              <a:t>B2G / B2C / гранты</a:t>
-            </a:r>
-            <a:endParaRPr lang="en-US" sz="1100" dirty="0"/>
+              <a:t>  ·  </a:t>
+            </a:r>
+            <a:pPr indent="0" marL="0">
+              <a:buNone/>
+            </a:pPr>
+            <a:r>
+              <a:rPr lang="en-US" sz="1000" b="1" dirty="0">
+                <a:solidFill>
+                  <a:srgbClr val="B07A45"/>
+                </a:solidFill>
+                <a:latin typeface="Arial" pitchFamily="34" charset="0"/>
+                <a:ea typeface="Arial" pitchFamily="34" charset="-122"/>
+                <a:cs typeface="Arial" pitchFamily="34" charset="-120"/>
+              </a:rPr>
+              <a:t>гранты 0,2%</a:t>
+            </a:r>
+            <a:endParaRPr lang="en-US" sz="1000" dirty="0"/>
           </a:p>
         </p:txBody>
       </p:sp>

</xml_diff>

<commit_message>
Pitch v8: average check for pansionat and caregiver services
Co-Authored-By: Claude Opus 5.5 <noreply@anthropic.com>
Claude-Session: https://claude.ai/code/session_01DZfKE2Qbh1BJBTBdA16C3f
</commit_message>
<xml_diff>
--- a/grant/Sodeystvie_pitch_v8.pptx
+++ b/grant/Sodeystvie_pitch_v8.pptx
@@ -7960,8 +7960,8 @@
         </p:nvSpPr>
         <p:spPr>
           <a:xfrm>
-            <a:off x="6839712" y="5349240"/>
-            <a:ext cx="1874520" cy="457200"/>
+            <a:off x="6839712" y="5340096"/>
+            <a:ext cx="1920240" cy="237744"/>
           </a:xfrm>
           <a:prstGeom prst="rect">
             <a:avLst/>
@@ -7977,7 +7977,7 @@
               <a:buNone/>
             </a:pPr>
             <a:r>
-              <a:rPr lang="en-US" sz="2200" b="1" dirty="0">
+              <a:rPr lang="en-US" sz="1500" b="1" dirty="0">
                 <a:solidFill>
                   <a:srgbClr val="064C49"/>
                 </a:solidFill>
@@ -7985,15 +7985,82 @@
                 <a:ea typeface="Arial" pitchFamily="34" charset="-122"/>
                 <a:cs typeface="Arial" pitchFamily="34" charset="-120"/>
               </a:rPr>
-              <a:t>2 600 ₽</a:t>
-            </a:r>
-            <a:endParaRPr lang="en-US" sz="2200" dirty="0"/>
+              <a:t>78 000 ₽</a:t>
+            </a:r>
+            <a:pPr indent="0" marL="0">
+              <a:buNone/>
+            </a:pPr>
+            <a:r>
+              <a:rPr lang="en-US" sz="1050" dirty="0">
+                <a:solidFill>
+                  <a:srgbClr val="5F6B70"/>
+                </a:solidFill>
+                <a:latin typeface="Arial" pitchFamily="34" charset="0"/>
+                <a:ea typeface="Arial" pitchFamily="34" charset="-122"/>
+                <a:cs typeface="Arial" pitchFamily="34" charset="-120"/>
+              </a:rPr>
+              <a:t>  пансионат</a:t>
+            </a:r>
+            <a:endParaRPr lang="en-US" sz="1500" dirty="0"/>
           </a:p>
         </p:txBody>
       </p:sp>
       <p:sp>
         <p:nvSpPr>
           <p:cNvPr id="57" name="Text 46"/>
+          <p:cNvSpPr txBox="1"/>
+          <p:nvPr/>
+        </p:nvSpPr>
+        <p:spPr>
+          <a:xfrm>
+            <a:off x="6839712" y="5568696"/>
+            <a:ext cx="1920240" cy="237744"/>
+          </a:xfrm>
+          <a:prstGeom prst="rect">
+            <a:avLst/>
+          </a:prstGeom>
+          <a:noFill/>
+          <a:ln/>
+        </p:spPr>
+        <p:txBody>
+          <a:bodyPr wrap="square" lIns="0" tIns="0" rIns="0" bIns="0" rtlCol="0" anchor="ctr"/>
+          <a:lstStyle/>
+          <a:p>
+            <a:pPr indent="0" marL="0">
+              <a:buNone/>
+            </a:pPr>
+            <a:r>
+              <a:rPr lang="en-US" sz="1500" b="1" dirty="0">
+                <a:solidFill>
+                  <a:srgbClr val="064C49"/>
+                </a:solidFill>
+                <a:latin typeface="Arial" pitchFamily="34" charset="0"/>
+                <a:ea typeface="Arial" pitchFamily="34" charset="-122"/>
+                <a:cs typeface="Arial" pitchFamily="34" charset="-120"/>
+              </a:rPr>
+              <a:t>26 400 ₽</a:t>
+            </a:r>
+            <a:pPr indent="0" marL="0">
+              <a:buNone/>
+            </a:pPr>
+            <a:r>
+              <a:rPr lang="en-US" sz="1050" dirty="0">
+                <a:solidFill>
+                  <a:srgbClr val="5F6B70"/>
+                </a:solidFill>
+                <a:latin typeface="Arial" pitchFamily="34" charset="0"/>
+                <a:ea typeface="Arial" pitchFamily="34" charset="-122"/>
+                <a:cs typeface="Arial" pitchFamily="34" charset="-120"/>
+              </a:rPr>
+              <a:t>  сиделка</a:t>
+            </a:r>
+            <a:endParaRPr lang="en-US" sz="1500" dirty="0"/>
+          </a:p>
+        </p:txBody>
+      </p:sp>
+      <p:sp>
+        <p:nvSpPr>
+          <p:cNvPr id="58" name="Text 47"/>
           <p:cNvSpPr txBox="1"/>
           <p:nvPr/>
         </p:nvSpPr>
@@ -8024,7 +8091,7 @@
                 <a:ea typeface="Arial" pitchFamily="34" charset="-122"/>
                 <a:cs typeface="Arial" pitchFamily="34" charset="-120"/>
               </a:rPr>
-              <a:t>средний чек, пансионат</a:t>
+              <a:t>средний чек в месяц</a:t>
             </a:r>
             <a:endParaRPr lang="en-US" sz="1050" dirty="0"/>
           </a:p>
@@ -8032,7 +8099,7 @@
       </p:sp>
       <p:sp>
         <p:nvSpPr>
-          <p:cNvPr id="58" name="Shape 47"/>
+          <p:cNvPr id="59" name="Shape 48"/>
           <p:cNvSpPr/>
           <p:nvPr/>
         </p:nvSpPr>
@@ -8055,7 +8122,7 @@
       </p:sp>
       <p:sp>
         <p:nvSpPr>
-          <p:cNvPr id="59" name="Text 48"/>
+          <p:cNvPr id="60" name="Text 49"/>
           <p:cNvSpPr txBox="1"/>
           <p:nvPr/>
         </p:nvSpPr>
@@ -8094,7 +8161,7 @@
       </p:sp>
       <p:sp>
         <p:nvSpPr>
-          <p:cNvPr id="60" name="Shape 49"/>
+          <p:cNvPr id="61" name="Shape 50"/>
           <p:cNvSpPr/>
           <p:nvPr/>
         </p:nvSpPr>
@@ -8119,7 +8186,7 @@
       </p:sp>
       <p:sp>
         <p:nvSpPr>
-          <p:cNvPr id="61" name="Shape 50"/>
+          <p:cNvPr id="62" name="Shape 51"/>
           <p:cNvSpPr/>
           <p:nvPr/>
         </p:nvSpPr>
@@ -8144,7 +8211,7 @@
       </p:sp>
       <p:sp>
         <p:nvSpPr>
-          <p:cNvPr id="62" name="Shape 51"/>
+          <p:cNvPr id="63" name="Shape 52"/>
           <p:cNvSpPr/>
           <p:nvPr/>
         </p:nvSpPr>
@@ -8169,7 +8236,7 @@
       </p:sp>
       <p:sp>
         <p:nvSpPr>
-          <p:cNvPr id="63" name="Text 52"/>
+          <p:cNvPr id="64" name="Text 53"/>
           <p:cNvSpPr txBox="1"/>
           <p:nvPr/>
         </p:nvSpPr>

</xml_diff>

<commit_message>
Pitch v8: full list of group entities in footnote, 2026 labeled as year-end forecast
Co-Authored-By: Claude Opus 5.5 <noreply@anthropic.com>
Claude-Session: https://claude.ai/code/session_01DZfKE2Qbh1BJBTBdA16C3f
</commit_message>
<xml_diff>
--- a/grant/Sodeystvie_pitch_v8.pptx
+++ b/grant/Sodeystvie_pitch_v8.pptx
@@ -2316,7 +2316,7 @@
                 <a:ea typeface="Arial" pitchFamily="34" charset="-122"/>
                 <a:cs typeface="Arial" pitchFamily="34" charset="-120"/>
               </a:rPr>
-              <a:t>* Показатели группы организаций «Содействие» (АНО ЦСО, АНО РЦСП, АНО ПЦСП «Содействие») — единая система долговременного ухода, созданная под руководством П. А. Петровой</a:t>
+              <a:t>* Показатели группы «Содействие» (АНО ЦСП, АНО ЦСО, АНО РЦСП, АНО ПЦСП «Содействие», ИП Петрова П. А.) — единая система долговременного ухода, созданная под руководством П. А. Петровой</a:t>
             </a:r>
             <a:endParaRPr lang="en-US" sz="800" dirty="0"/>
           </a:p>
@@ -4500,7 +4500,7 @@
                 <a:ea typeface="Arial" pitchFamily="34" charset="-122"/>
                 <a:cs typeface="Arial" pitchFamily="34" charset="-120"/>
               </a:rPr>
-              <a:t>* Показатели группы организаций «Содействие» (АНО ЦСО, АНО РЦСП, АНО ПЦСП «Содействие») — единая система долговременного ухода, созданная под руководством П. А. Петровой</a:t>
+              <a:t>* Показатели группы «Содействие» (АНО ЦСП, АНО ЦСО, АНО РЦСП, АНО ПЦСП «Содействие», ИП Петрова П. А.) — единая система долговременного ухода, созданная под руководством П. А. Петровой</a:t>
             </a:r>
             <a:endParaRPr lang="en-US" sz="850" dirty="0"/>
           </a:p>
@@ -6363,7 +6363,7 @@
                 <a:ea typeface="Arial" pitchFamily="34" charset="-122"/>
                 <a:cs typeface="Arial" pitchFamily="34" charset="-120"/>
               </a:rPr>
-              <a:t>* Показатели группы организаций «Содействие» (АНО ЦСО, АНО РЦСП, АНО ПЦСП «Содействие») — единая система долговременного ухода, созданная под руководством П. А. Петровой</a:t>
+              <a:t>* Показатели группы «Содействие» (АНО ЦСП, АНО ЦСО, АНО РЦСП, АНО ПЦСП «Содействие», ИП Петрова П. А.) — единая система долговременного ухода, созданная под руководством П. А. Петровой</a:t>
             </a:r>
             <a:endParaRPr lang="en-US" sz="850" dirty="0"/>
           </a:p>
@@ -7822,7 +7822,7 @@
                 <a:ea typeface="Arial" pitchFamily="34" charset="-122"/>
                 <a:cs typeface="Arial" pitchFamily="34" charset="-120"/>
               </a:rPr>
-              <a:t>прогноз 2026, +30% к 2025</a:t>
+              <a:t>прогноз на конец 2026, +30%</a:t>
             </a:r>
             <a:endParaRPr lang="en-US" sz="1050" dirty="0"/>
           </a:p>
@@ -8577,7 +8577,7 @@
                 <a:ea typeface="Arial" pitchFamily="34" charset="-122"/>
                 <a:cs typeface="Arial" pitchFamily="34" charset="-120"/>
               </a:rPr>
-              <a:t>* Показатели группы организаций «Содействие» (АНО ЦСО, АНО РЦСП, АНО ПЦСП «Содействие») — единая система долговременного ухода, созданная под руководством П. А. Петровой</a:t>
+              <a:t>* Показатели группы «Содействие» (АНО ЦСП, АНО ЦСО, АНО РЦСП, АНО ПЦСП «Содействие», ИП Петрова П. А.) — единая система долговременного ухода, созданная под руководством П. А. Петровой</a:t>
             </a:r>
             <a:endParaRPr lang="en-US" sz="850" dirty="0"/>
           </a:p>
@@ -10150,7 +10150,7 @@
                 <a:ea typeface="Arial" pitchFamily="34" charset="-122"/>
                 <a:cs typeface="Arial" pitchFamily="34" charset="-120"/>
               </a:rPr>
-              <a:t>* Показатели группы организаций «Содействие» (АНО ЦСО, АНО РЦСП, АНО ПЦСП «Содействие») — единая система долговременного ухода, созданная под руководством П. А. Петровой</a:t>
+              <a:t>* Показатели группы «Содействие» (АНО ЦСП, АНО ЦСО, АНО РЦСП, АНО ПЦСП «Содействие», ИП Петрова П. А.) — единая система долговременного ухода, созданная под руководством П. А. Петровой</a:t>
             </a:r>
             <a:endParaRPr lang="en-US" sz="850" dirty="0"/>
           </a:p>

</xml_diff>